<commit_message>
docs: add prefill timeline for KV-pool load plus local recompute
Show the token split, the layer dependency, and the waits that land in TTFT when a history load runs longer than local compute.

Co-authored-by: 69515164-rgb <69515164-rgb@users.noreply.github.com>
</commit_message>
<xml_diff>
--- a/docs/kv-handoff-timeline.pptx
+++ b/docs/kv-handoff-timeline.pptx
@@ -6,6 +6,7 @@
   </p:sldMasterIdLst>
   <p:sldIdLst>
     <p:sldId id="256" r:id="rId7"/>
+    <p:sldId id="257" r:id="rId9"/>
   </p:sldIdLst>
   <p:sldSz cx="12191695" cy="6858000" type="screen4x3"/>
   <p:notesSz cx="6858000" cy="9144000"/>
@@ -503,6 +504,76 @@
           <a:p>
             <a:r>
               <a:t>时序按 DistServe 的定义：TTFT 是 prefill 阶段，首 token 在 prefill 侧生成；TPOT 从第二个 token 起算。按层搬运见 Splitwise / DéjàVu 以及后续的 SmartGen、BanaServe：算完一层即可送往已经选定的 decode。历史前缀来自 KV 池，只依赖目的地，可与本次 prefill 并行。露出的时间 = max(0, 单条搬运时间 - prefill 计算时间)。DistServe 的平均速率条件：所需带宽 = 每秒完成的 prefill 条数 × 单条 KV 字节 × 8。OPT-66B、512 token 约 1.13 GB，10 次/秒约合 90 Gbps，低于此带宽则排队积累。</a:t>
+            </a:r>
+          </a:p>
+        </p:txBody>
+      </p:sp>
+      <p:sp>
+        <p:nvSpPr>
+          <p:cNvPr id="4" name="Slide Number Placeholder 3"/>
+          <p:cNvSpPr>
+            <a:spLocks noGrp="1"/>
+          </p:cNvSpPr>
+          <p:nvPr>
+            <p:ph type="sldNum" idx="5" sz="quarter"/>
+          </p:nvPr>
+        </p:nvSpPr>
+        <p:spPr/>
+      </p:sp>
+    </p:spTree>
+  </p:cSld>
+  <p:clrMapOvr>
+    <a:masterClrMapping/>
+  </p:clrMapOvr>
+</p:notes>
+</file>
+
+<file path=ppt/notesSlides/notesSlide2.xml><?xml version="1.0" encoding="utf-8"?>
+<p:notes xmlns:a="http://schemas.openxmlformats.org/drawingml/2006/main" xmlns:p="http://schemas.openxmlformats.org/presentationml/2006/main" xmlns:r="http://schemas.openxmlformats.org/officeDocument/2006/relationships">
+  <p:cSld>
+    <p:spTree>
+      <p:nvGrpSpPr>
+        <p:cNvPr id="1" name=""/>
+        <p:cNvGrpSpPr/>
+        <p:nvPr/>
+      </p:nvGrpSpPr>
+      <p:grpSpPr>
+        <a:xfrm>
+          <a:off x="0" y="0"/>
+          <a:ext cx="0" cy="0"/>
+          <a:chOff x="0" y="0"/>
+          <a:chExt cx="0" cy="0"/>
+        </a:xfrm>
+      </p:grpSpPr>
+      <p:sp>
+        <p:nvSpPr>
+          <p:cNvPr id="2" name="Slide Image Placeholder 1"/>
+          <p:cNvSpPr>
+            <a:spLocks noGrp="1"/>
+          </p:cNvSpPr>
+          <p:nvPr>
+            <p:ph type="sldImg" idx="2"/>
+          </p:nvPr>
+        </p:nvSpPr>
+        <p:spPr/>
+      </p:sp>
+      <p:sp>
+        <p:nvSpPr>
+          <p:cNvPr id="3" name="Notes Placeholder 2"/>
+          <p:cNvSpPr>
+            <a:spLocks noGrp="1"/>
+          </p:cNvSpPr>
+          <p:nvPr>
+            <p:ph type="body" idx="3" sz="quarter"/>
+          </p:nvPr>
+        </p:nvSpPr>
+        <p:spPr/>
+        <p:txBody>
+          <a:bodyPr/>
+          <a:lstStyle/>
+          <a:p>
+            <a:r>
+              <a:t>上下文先切成两段：KV 池里已经有的历史段只读取，未命中的一段在本地重计算。依赖在层上：本地计算第 i 层的 attention 之前，第 i 层的历史 KV 必须已经到位。读取第 i+1 层可以和本地计算第 i 层重叠。读取慢于计算时，两层之间出现等待，这段在首 token 之前，进入 TTFT。层间等待 = max(0, 该层历史 KV 读完的时刻 - 上一层本地算完的时刻)。若某一小段在本地重算比从池里读取更便宜，就把这一段从读取改成重算，用来消掉等待。</a:t>
             </a:r>
           </a:p>
         </p:txBody>
@@ -3588,7 +3659,7 @@
                 <a:ea typeface="Microsoft YaHei"/>
                 <a:cs typeface="Microsoft YaHei"/>
               </a:rPr>
-              <a:t>PD 分离  ·  KV 交接</a:t>
+              <a:t>PD 分离  ·  KV 交接    1 / 2</a:t>
             </a:r>
           </a:p>
         </p:txBody>
@@ -5658,6 +5729,2213 @@
                 <a:cs typeface="Microsoft YaHei"/>
               </a:rPr>
               <a:t>露出的时间 = max(0, 单条搬运时间 - prefill 计算时间)。图中每层搬运与每层计算等长，所以露出正好是最后一层；搬运更慢时，气泡再往右长。</a:t>
+            </a:r>
+          </a:p>
+        </p:txBody>
+      </p:sp>
+    </p:spTree>
+  </p:cSld>
+  <p:clrMapOvr>
+    <a:masterClrMapping/>
+  </p:clrMapOvr>
+</p:sld>
+</file>
+
+<file path=ppt/slides/slide2.xml><?xml version="1.0" encoding="utf-8"?>
+<p:sld xmlns:a="http://schemas.openxmlformats.org/drawingml/2006/main" xmlns:p="http://schemas.openxmlformats.org/presentationml/2006/main" xmlns:r="http://schemas.openxmlformats.org/officeDocument/2006/relationships">
+  <p:cSld>
+    <p:spTree>
+      <p:nvGrpSpPr>
+        <p:cNvPr id="1" name=""/>
+        <p:cNvGrpSpPr/>
+        <p:nvPr/>
+      </p:nvGrpSpPr>
+      <p:grpSpPr/>
+      <p:sp>
+        <p:nvSpPr>
+          <p:cNvPr id="2" name="Rectangle 1"/>
+          <p:cNvSpPr/>
+          <p:nvPr/>
+        </p:nvSpPr>
+        <p:spPr>
+          <a:xfrm>
+            <a:off x="0" y="0"/>
+            <a:ext cx="12191695" cy="73152"/>
+          </a:xfrm>
+          <a:prstGeom prst="rect">
+            <a:avLst/>
+          </a:prstGeom>
+          <a:solidFill>
+            <a:srgbClr val="145A96"/>
+          </a:solidFill>
+          <a:ln>
+            <a:noFill/>
+          </a:ln>
+        </p:spPr>
+        <p:style>
+          <a:lnRef idx="1">
+            <a:schemeClr val="accent1"/>
+          </a:lnRef>
+          <a:fillRef idx="3">
+            <a:schemeClr val="accent1"/>
+          </a:fillRef>
+          <a:effectRef idx="2">
+            <a:schemeClr val="accent1"/>
+          </a:effectRef>
+          <a:fontRef idx="minor">
+            <a:schemeClr val="lt1"/>
+          </a:fontRef>
+        </p:style>
+        <p:txBody>
+          <a:bodyPr rtlCol="0" anchor="ctr"/>
+          <a:lstStyle/>
+          <a:p>
+            <a:pPr algn="ctr"/>
+          </a:p>
+        </p:txBody>
+      </p:sp>
+      <p:sp>
+        <p:nvSpPr>
+          <p:cNvPr id="3" name="TextBox 2"/>
+          <p:cNvSpPr txBox="1"/>
+          <p:nvPr/>
+        </p:nvSpPr>
+        <p:spPr>
+          <a:xfrm>
+            <a:off x="292608" y="128016"/>
+            <a:ext cx="11338560" cy="201168"/>
+          </a:xfrm>
+          <a:prstGeom prst="rect">
+            <a:avLst/>
+          </a:prstGeom>
+          <a:noFill/>
+        </p:spPr>
+        <p:txBody>
+          <a:bodyPr wrap="square" lIns="0" rIns="0" tIns="0" bIns="0" anchor="ctr"/>
+          <a:lstStyle/>
+          <a:p>
+            <a:pPr algn="l">
+              <a:spcBef>
+                <a:spcPts val="0"/>
+              </a:spcBef>
+              <a:spcAft>
+                <a:spcPts val="0"/>
+              </a:spcAft>
+            </a:pPr>
+            <a:r>
+              <a:rPr sz="1200" b="1">
+                <a:solidFill>
+                  <a:srgbClr val="145A96"/>
+                </a:solidFill>
+                <a:latin typeface="Microsoft YaHei"/>
+                <a:ea typeface="Microsoft YaHei"/>
+                <a:cs typeface="Microsoft YaHei"/>
+              </a:rPr>
+              <a:t>PD 分离  ·  Prefill 与 KV 池    2 / 2</a:t>
+            </a:r>
+          </a:p>
+        </p:txBody>
+      </p:sp>
+      <p:sp>
+        <p:nvSpPr>
+          <p:cNvPr id="4" name="TextBox 3"/>
+          <p:cNvSpPr txBox="1"/>
+          <p:nvPr/>
+        </p:nvSpPr>
+        <p:spPr>
+          <a:xfrm>
+            <a:off x="292608" y="329184"/>
+            <a:ext cx="11521440" cy="310896"/>
+          </a:xfrm>
+          <a:prstGeom prst="rect">
+            <a:avLst/>
+          </a:prstGeom>
+          <a:noFill/>
+        </p:spPr>
+        <p:txBody>
+          <a:bodyPr wrap="square" lIns="0" rIns="0" tIns="0" bIns="0" anchor="ctr"/>
+          <a:lstStyle/>
+          <a:p>
+            <a:pPr algn="l">
+              <a:spcBef>
+                <a:spcPts val="0"/>
+              </a:spcBef>
+              <a:spcAft>
+                <a:spcPts val="0"/>
+              </a:spcAft>
+            </a:pPr>
+            <a:r>
+              <a:rPr sz="2400" b="1">
+                <a:solidFill>
+                  <a:srgbClr val="0E2A47"/>
+                </a:solidFill>
+                <a:latin typeface="Microsoft YaHei"/>
+                <a:ea typeface="Microsoft YaHei"/>
+                <a:cs typeface="Microsoft YaHei"/>
+              </a:rPr>
+              <a:t>读历史 KV，本地只重算未命中的一段</a:t>
+            </a:r>
+          </a:p>
+        </p:txBody>
+      </p:sp>
+      <p:sp>
+        <p:nvSpPr>
+          <p:cNvPr id="5" name="Rectangle 4"/>
+          <p:cNvSpPr/>
+          <p:nvPr/>
+        </p:nvSpPr>
+        <p:spPr>
+          <a:xfrm>
+            <a:off x="292608" y="713232"/>
+            <a:ext cx="64008" cy="329184"/>
+          </a:xfrm>
+          <a:prstGeom prst="rect">
+            <a:avLst/>
+          </a:prstGeom>
+          <a:solidFill>
+            <a:srgbClr val="145A96"/>
+          </a:solidFill>
+          <a:ln>
+            <a:noFill/>
+          </a:ln>
+        </p:spPr>
+        <p:style>
+          <a:lnRef idx="1">
+            <a:schemeClr val="accent1"/>
+          </a:lnRef>
+          <a:fillRef idx="3">
+            <a:schemeClr val="accent1"/>
+          </a:fillRef>
+          <a:effectRef idx="2">
+            <a:schemeClr val="accent1"/>
+          </a:effectRef>
+          <a:fontRef idx="minor">
+            <a:schemeClr val="lt1"/>
+          </a:fontRef>
+        </p:style>
+        <p:txBody>
+          <a:bodyPr rtlCol="0" anchor="ctr"/>
+          <a:lstStyle/>
+          <a:p>
+            <a:pPr algn="ctr"/>
+          </a:p>
+        </p:txBody>
+      </p:sp>
+      <p:sp>
+        <p:nvSpPr>
+          <p:cNvPr id="6" name="TextBox 5"/>
+          <p:cNvSpPr txBox="1"/>
+          <p:nvPr/>
+        </p:nvSpPr>
+        <p:spPr>
+          <a:xfrm>
+            <a:off x="438912" y="676656"/>
+            <a:ext cx="11430000" cy="384048"/>
+          </a:xfrm>
+          <a:prstGeom prst="rect">
+            <a:avLst/>
+          </a:prstGeom>
+          <a:noFill/>
+        </p:spPr>
+        <p:txBody>
+          <a:bodyPr wrap="square" lIns="0" rIns="0" tIns="0" bIns="0" anchor="ctr"/>
+          <a:lstStyle/>
+          <a:p>
+            <a:pPr algn="l">
+              <a:spcBef>
+                <a:spcPts val="0"/>
+              </a:spcBef>
+              <a:spcAft>
+                <a:spcPts val="0"/>
+              </a:spcAft>
+            </a:pPr>
+            <a:r>
+              <a:rPr sz="1400" b="1">
+                <a:solidFill>
+                  <a:srgbClr val="1C242E"/>
+                </a:solidFill>
+                <a:latin typeface="Microsoft YaHei"/>
+                <a:ea typeface="Microsoft YaHei"/>
+                <a:cs typeface="Microsoft YaHei"/>
+              </a:rPr>
+              <a:t>历史段按层从 KV 池读，未命中的一段在本地算。同一层要等历史 KV 到位才能算。读得比算得慢时，等待出现在首 token 之前。</a:t>
+            </a:r>
+          </a:p>
+        </p:txBody>
+      </p:sp>
+      <p:sp>
+        <p:nvSpPr>
+          <p:cNvPr id="7" name="TextBox 6"/>
+          <p:cNvSpPr txBox="1"/>
+          <p:nvPr/>
+        </p:nvSpPr>
+        <p:spPr>
+          <a:xfrm>
+            <a:off x="256032" y="1133856"/>
+            <a:ext cx="1389888" cy="329184"/>
+          </a:xfrm>
+          <a:prstGeom prst="rect">
+            <a:avLst/>
+          </a:prstGeom>
+          <a:noFill/>
+        </p:spPr>
+        <p:txBody>
+          <a:bodyPr wrap="square" lIns="0" rIns="0" tIns="0" bIns="0" anchor="ctr"/>
+          <a:lstStyle/>
+          <a:p>
+            <a:pPr algn="l">
+              <a:spcBef>
+                <a:spcPts val="0"/>
+              </a:spcBef>
+              <a:spcAft>
+                <a:spcPts val="0"/>
+              </a:spcAft>
+            </a:pPr>
+            <a:r>
+              <a:rPr sz="1300" b="1">
+                <a:solidFill>
+                  <a:srgbClr val="0E2A47"/>
+                </a:solidFill>
+                <a:latin typeface="Microsoft YaHei"/>
+                <a:ea typeface="Microsoft YaHei"/>
+                <a:cs typeface="Microsoft YaHei"/>
+              </a:rPr>
+              <a:t>上下文切分</a:t>
+            </a:r>
+          </a:p>
+        </p:txBody>
+      </p:sp>
+      <p:sp>
+        <p:nvSpPr>
+          <p:cNvPr id="8" name="Rectangle 7"/>
+          <p:cNvSpPr/>
+          <p:nvPr/>
+        </p:nvSpPr>
+        <p:spPr>
+          <a:xfrm>
+            <a:off x="1719072" y="1133856"/>
+            <a:ext cx="6944867" cy="329184"/>
+          </a:xfrm>
+          <a:prstGeom prst="rect">
+            <a:avLst/>
+          </a:prstGeom>
+          <a:solidFill>
+            <a:srgbClr val="8C6424"/>
+          </a:solidFill>
+          <a:ln>
+            <a:noFill/>
+          </a:ln>
+        </p:spPr>
+        <p:style>
+          <a:lnRef idx="1">
+            <a:schemeClr val="accent1"/>
+          </a:lnRef>
+          <a:fillRef idx="3">
+            <a:schemeClr val="accent1"/>
+          </a:fillRef>
+          <a:effectRef idx="2">
+            <a:schemeClr val="accent1"/>
+          </a:effectRef>
+          <a:fontRef idx="minor">
+            <a:schemeClr val="lt1"/>
+          </a:fontRef>
+        </p:style>
+        <p:txBody>
+          <a:bodyPr rtlCol="0" anchor="ctr" wrap="square" lIns="36576" rIns="36576" tIns="18288" bIns="18288"/>
+          <a:lstStyle/>
+          <a:p>
+            <a:pPr algn="ctr">
+              <a:spcBef>
+                <a:spcPts val="0"/>
+              </a:spcBef>
+              <a:spcAft>
+                <a:spcPts val="0"/>
+              </a:spcAft>
+            </a:pPr>
+            <a:r>
+              <a:rPr sz="1300" b="1">
+                <a:solidFill>
+                  <a:srgbClr val="FFFFFF"/>
+                </a:solidFill>
+                <a:latin typeface="Microsoft YaHei"/>
+                <a:ea typeface="Microsoft YaHei"/>
+                <a:cs typeface="Microsoft YaHei"/>
+              </a:rPr>
+              <a:t>历史段：KV 池已有，只读取</a:t>
+            </a:r>
+          </a:p>
+        </p:txBody>
+      </p:sp>
+      <p:sp>
+        <p:nvSpPr>
+          <p:cNvPr id="9" name="Rectangle 8"/>
+          <p:cNvSpPr/>
+          <p:nvPr/>
+        </p:nvSpPr>
+        <p:spPr>
+          <a:xfrm>
+            <a:off x="8663939" y="1133856"/>
+            <a:ext cx="2976372" cy="329184"/>
+          </a:xfrm>
+          <a:prstGeom prst="rect">
+            <a:avLst/>
+          </a:prstGeom>
+          <a:solidFill>
+            <a:srgbClr val="145A96"/>
+          </a:solidFill>
+          <a:ln>
+            <a:noFill/>
+          </a:ln>
+        </p:spPr>
+        <p:style>
+          <a:lnRef idx="1">
+            <a:schemeClr val="accent1"/>
+          </a:lnRef>
+          <a:fillRef idx="3">
+            <a:schemeClr val="accent1"/>
+          </a:fillRef>
+          <a:effectRef idx="2">
+            <a:schemeClr val="accent1"/>
+          </a:effectRef>
+          <a:fontRef idx="minor">
+            <a:schemeClr val="lt1"/>
+          </a:fontRef>
+        </p:style>
+        <p:txBody>
+          <a:bodyPr rtlCol="0" anchor="ctr" wrap="square" lIns="36576" rIns="36576" tIns="18288" bIns="18288"/>
+          <a:lstStyle/>
+          <a:p>
+            <a:pPr algn="ctr">
+              <a:spcBef>
+                <a:spcPts val="0"/>
+              </a:spcBef>
+              <a:spcAft>
+                <a:spcPts val="0"/>
+              </a:spcAft>
+            </a:pPr>
+            <a:r>
+              <a:rPr sz="1300" b="1">
+                <a:solidFill>
+                  <a:srgbClr val="FFFFFF"/>
+                </a:solidFill>
+                <a:latin typeface="Microsoft YaHei"/>
+                <a:ea typeface="Microsoft YaHei"/>
+                <a:cs typeface="Microsoft YaHei"/>
+              </a:rPr>
+              <a:t>重算段：未命中，本地计算</a:t>
+            </a:r>
+          </a:p>
+        </p:txBody>
+      </p:sp>
+      <p:sp>
+        <p:nvSpPr>
+          <p:cNvPr id="10" name="TextBox 9"/>
+          <p:cNvSpPr txBox="1"/>
+          <p:nvPr/>
+        </p:nvSpPr>
+        <p:spPr>
+          <a:xfrm>
+            <a:off x="1719072" y="1463040"/>
+            <a:ext cx="9921240" cy="201168"/>
+          </a:xfrm>
+          <a:prstGeom prst="rect">
+            <a:avLst/>
+          </a:prstGeom>
+          <a:noFill/>
+        </p:spPr>
+        <p:txBody>
+          <a:bodyPr wrap="square" lIns="0" rIns="0" tIns="0" bIns="0" anchor="ctr"/>
+          <a:lstStyle/>
+          <a:p>
+            <a:pPr algn="l">
+              <a:spcBef>
+                <a:spcPts val="0"/>
+              </a:spcBef>
+              <a:spcAft>
+                <a:spcPts val="0"/>
+              </a:spcAft>
+            </a:pPr>
+            <a:r>
+              <a:rPr sz="1100" b="0">
+                <a:solidFill>
+                  <a:srgbClr val="5A636E"/>
+                </a:solidFill>
+                <a:latin typeface="Microsoft YaHei"/>
+                <a:ea typeface="Microsoft YaHei"/>
+                <a:cs typeface="Microsoft YaHei"/>
+              </a:rPr>
+              <a:t>上面是 token 切分，不是时间轴。下面每一格才是时间。</a:t>
+            </a:r>
+          </a:p>
+        </p:txBody>
+      </p:sp>
+      <p:sp>
+        <p:nvSpPr>
+          <p:cNvPr id="11" name="Rectangle 10"/>
+          <p:cNvSpPr/>
+          <p:nvPr/>
+        </p:nvSpPr>
+        <p:spPr>
+          <a:xfrm>
+            <a:off x="1719072" y="1719072"/>
+            <a:ext cx="10030968" cy="1591056"/>
+          </a:xfrm>
+          <a:prstGeom prst="rect">
+            <a:avLst/>
+          </a:prstGeom>
+          <a:solidFill>
+            <a:srgbClr val="E8F3F2"/>
+          </a:solidFill>
+          <a:ln>
+            <a:noFill/>
+          </a:ln>
+        </p:spPr>
+        <p:style>
+          <a:lnRef idx="1">
+            <a:schemeClr val="accent1"/>
+          </a:lnRef>
+          <a:fillRef idx="3">
+            <a:schemeClr val="accent1"/>
+          </a:fillRef>
+          <a:effectRef idx="2">
+            <a:schemeClr val="accent1"/>
+          </a:effectRef>
+          <a:fontRef idx="minor">
+            <a:schemeClr val="lt1"/>
+          </a:fontRef>
+        </p:style>
+        <p:txBody>
+          <a:bodyPr rtlCol="0" anchor="ctr"/>
+          <a:lstStyle/>
+          <a:p>
+            <a:pPr algn="ctr"/>
+          </a:p>
+        </p:txBody>
+      </p:sp>
+      <p:sp>
+        <p:nvSpPr>
+          <p:cNvPr id="12" name="TextBox 11"/>
+          <p:cNvSpPr txBox="1"/>
+          <p:nvPr/>
+        </p:nvSpPr>
+        <p:spPr>
+          <a:xfrm>
+            <a:off x="1719072" y="1719072"/>
+            <a:ext cx="9070848" cy="219456"/>
+          </a:xfrm>
+          <a:prstGeom prst="rect">
+            <a:avLst/>
+          </a:prstGeom>
+          <a:noFill/>
+        </p:spPr>
+        <p:txBody>
+          <a:bodyPr wrap="square" lIns="0" rIns="0" tIns="0" bIns="0" anchor="ctr"/>
+          <a:lstStyle/>
+          <a:p>
+            <a:pPr algn="ctr">
+              <a:spcBef>
+                <a:spcPts val="0"/>
+              </a:spcBef>
+              <a:spcAft>
+                <a:spcPts val="0"/>
+              </a:spcAft>
+            </a:pPr>
+            <a:r>
+              <a:rPr sz="1200" b="1">
+                <a:solidFill>
+                  <a:srgbClr val="0E7A76"/>
+                </a:solidFill>
+                <a:latin typeface="Microsoft YaHei"/>
+                <a:ea typeface="Microsoft YaHei"/>
+                <a:cs typeface="Microsoft YaHei"/>
+              </a:rPr>
+              <a:t>时间  →    读历史可与上一层本地计算重叠</a:t>
+            </a:r>
+          </a:p>
+        </p:txBody>
+      </p:sp>
+      <p:sp>
+        <p:nvSpPr>
+          <p:cNvPr id="13" name="TextBox 12"/>
+          <p:cNvSpPr txBox="1"/>
+          <p:nvPr/>
+        </p:nvSpPr>
+        <p:spPr>
+          <a:xfrm>
+            <a:off x="10652760" y="1719072"/>
+            <a:ext cx="1143000" cy="219456"/>
+          </a:xfrm>
+          <a:prstGeom prst="rect">
+            <a:avLst/>
+          </a:prstGeom>
+          <a:noFill/>
+        </p:spPr>
+        <p:txBody>
+          <a:bodyPr wrap="square" lIns="0" rIns="0" tIns="0" bIns="0" anchor="ctr"/>
+          <a:lstStyle/>
+          <a:p>
+            <a:pPr algn="ctr">
+              <a:spcBef>
+                <a:spcPts val="0"/>
+              </a:spcBef>
+              <a:spcAft>
+                <a:spcPts val="0"/>
+              </a:spcAft>
+            </a:pPr>
+            <a:r>
+              <a:rPr sz="1200" b="1">
+                <a:solidFill>
+                  <a:srgbClr val="1B6E48"/>
+                </a:solidFill>
+                <a:latin typeface="Microsoft YaHei"/>
+                <a:ea typeface="Microsoft YaHei"/>
+                <a:cs typeface="Microsoft YaHei"/>
+              </a:rPr>
+              <a:t>首 token</a:t>
+            </a:r>
+          </a:p>
+        </p:txBody>
+      </p:sp>
+      <p:sp>
+        <p:nvSpPr>
+          <p:cNvPr id="14" name="TextBox 13"/>
+          <p:cNvSpPr txBox="1"/>
+          <p:nvPr/>
+        </p:nvSpPr>
+        <p:spPr>
+          <a:xfrm>
+            <a:off x="256032" y="1975104"/>
+            <a:ext cx="1389888" cy="530352"/>
+          </a:xfrm>
+          <a:prstGeom prst="rect">
+            <a:avLst/>
+          </a:prstGeom>
+          <a:noFill/>
+        </p:spPr>
+        <p:txBody>
+          <a:bodyPr wrap="square" lIns="0" rIns="0" tIns="0" bIns="0" anchor="ctr"/>
+          <a:lstStyle/>
+          <a:p>
+            <a:pPr algn="l">
+              <a:spcBef>
+                <a:spcPts val="0"/>
+              </a:spcBef>
+              <a:spcAft>
+                <a:spcPts val="0"/>
+              </a:spcAft>
+            </a:pPr>
+            <a:r>
+              <a:rPr sz="1300" b="1">
+                <a:solidFill>
+                  <a:srgbClr val="0E2A47"/>
+                </a:solidFill>
+                <a:latin typeface="Microsoft YaHei"/>
+                <a:ea typeface="Microsoft YaHei"/>
+                <a:cs typeface="Microsoft YaHei"/>
+              </a:rPr>
+              <a:t>KV 池读取</a:t>
+            </a:r>
+          </a:p>
+        </p:txBody>
+      </p:sp>
+      <p:sp>
+        <p:nvSpPr>
+          <p:cNvPr id="15" name="TextBox 14"/>
+          <p:cNvSpPr txBox="1"/>
+          <p:nvPr/>
+        </p:nvSpPr>
+        <p:spPr>
+          <a:xfrm>
+            <a:off x="256032" y="2779776"/>
+            <a:ext cx="1389888" cy="530352"/>
+          </a:xfrm>
+          <a:prstGeom prst="rect">
+            <a:avLst/>
+          </a:prstGeom>
+          <a:noFill/>
+        </p:spPr>
+        <p:txBody>
+          <a:bodyPr wrap="square" lIns="0" rIns="0" tIns="0" bIns="0" anchor="ctr"/>
+          <a:lstStyle/>
+          <a:p>
+            <a:pPr algn="l">
+              <a:spcBef>
+                <a:spcPts val="0"/>
+              </a:spcBef>
+              <a:spcAft>
+                <a:spcPts val="0"/>
+              </a:spcAft>
+            </a:pPr>
+            <a:r>
+              <a:rPr sz="1300" b="1">
+                <a:solidFill>
+                  <a:srgbClr val="0E2A47"/>
+                </a:solidFill>
+                <a:latin typeface="Microsoft YaHei"/>
+                <a:ea typeface="Microsoft YaHei"/>
+                <a:cs typeface="Microsoft YaHei"/>
+              </a:rPr>
+              <a:t>本地重计算</a:t>
+            </a:r>
+          </a:p>
+        </p:txBody>
+      </p:sp>
+      <p:sp>
+        <p:nvSpPr>
+          <p:cNvPr id="16" name="Rectangle 15"/>
+          <p:cNvSpPr/>
+          <p:nvPr/>
+        </p:nvSpPr>
+        <p:spPr>
+          <a:xfrm>
+            <a:off x="1773936" y="2048256"/>
+            <a:ext cx="932688" cy="384047"/>
+          </a:xfrm>
+          <a:prstGeom prst="rect">
+            <a:avLst/>
+          </a:prstGeom>
+          <a:solidFill>
+            <a:srgbClr val="0E2A47"/>
+          </a:solidFill>
+          <a:ln>
+            <a:noFill/>
+          </a:ln>
+        </p:spPr>
+        <p:style>
+          <a:lnRef idx="1">
+            <a:schemeClr val="accent1"/>
+          </a:lnRef>
+          <a:fillRef idx="3">
+            <a:schemeClr val="accent1"/>
+          </a:fillRef>
+          <a:effectRef idx="2">
+            <a:schemeClr val="accent1"/>
+          </a:effectRef>
+          <a:fontRef idx="minor">
+            <a:schemeClr val="lt1"/>
+          </a:fontRef>
+        </p:style>
+        <p:txBody>
+          <a:bodyPr rtlCol="0" anchor="ctr" wrap="square" lIns="36576" rIns="36576" tIns="18288" bIns="18288"/>
+          <a:lstStyle/>
+          <a:p>
+            <a:pPr algn="ctr">
+              <a:spcBef>
+                <a:spcPts val="0"/>
+              </a:spcBef>
+              <a:spcAft>
+                <a:spcPts val="0"/>
+              </a:spcAft>
+            </a:pPr>
+            <a:r>
+              <a:rPr sz="1200" b="1">
+                <a:solidFill>
+                  <a:srgbClr val="FFFFFF"/>
+                </a:solidFill>
+                <a:latin typeface="Microsoft YaHei"/>
+                <a:ea typeface="Microsoft YaHei"/>
+                <a:cs typeface="Microsoft YaHei"/>
+              </a:rPr>
+              <a:t>判定命中</a:t>
+            </a:r>
+          </a:p>
+        </p:txBody>
+      </p:sp>
+      <p:sp>
+        <p:nvSpPr>
+          <p:cNvPr id="17" name="TextBox 16"/>
+          <p:cNvSpPr txBox="1"/>
+          <p:nvPr/>
+        </p:nvSpPr>
+        <p:spPr>
+          <a:xfrm>
+            <a:off x="1773936" y="2779776"/>
+            <a:ext cx="950976" cy="530352"/>
+          </a:xfrm>
+          <a:prstGeom prst="rect">
+            <a:avLst/>
+          </a:prstGeom>
+          <a:noFill/>
+        </p:spPr>
+        <p:txBody>
+          <a:bodyPr wrap="square" lIns="0" rIns="0" tIns="0" bIns="0" anchor="ctr"/>
+          <a:lstStyle/>
+          <a:p>
+            <a:pPr algn="ctr">
+              <a:spcBef>
+                <a:spcPts val="0"/>
+              </a:spcBef>
+              <a:spcAft>
+                <a:spcPts val="0"/>
+              </a:spcAft>
+            </a:pPr>
+            <a:r>
+              <a:rPr sz="1100" b="1">
+                <a:solidFill>
+                  <a:srgbClr val="5A636E"/>
+                </a:solidFill>
+                <a:latin typeface="Microsoft YaHei"/>
+                <a:ea typeface="Microsoft YaHei"/>
+                <a:cs typeface="Microsoft YaHei"/>
+              </a:rPr>
+              <a:t>等切分完成</a:t>
+            </a:r>
+          </a:p>
+        </p:txBody>
+      </p:sp>
+      <p:sp>
+        <p:nvSpPr>
+          <p:cNvPr id="18" name="Rectangle 17"/>
+          <p:cNvSpPr/>
+          <p:nvPr/>
+        </p:nvSpPr>
+        <p:spPr>
+          <a:xfrm>
+            <a:off x="2743200" y="2029968"/>
+            <a:ext cx="1700784" cy="420623"/>
+          </a:xfrm>
+          <a:prstGeom prst="rect">
+            <a:avLst/>
+          </a:prstGeom>
+          <a:solidFill>
+            <a:srgbClr val="8C6424"/>
+          </a:solidFill>
+          <a:ln>
+            <a:noFill/>
+          </a:ln>
+        </p:spPr>
+        <p:style>
+          <a:lnRef idx="1">
+            <a:schemeClr val="accent1"/>
+          </a:lnRef>
+          <a:fillRef idx="3">
+            <a:schemeClr val="accent1"/>
+          </a:fillRef>
+          <a:effectRef idx="2">
+            <a:schemeClr val="accent1"/>
+          </a:effectRef>
+          <a:fontRef idx="minor">
+            <a:schemeClr val="lt1"/>
+          </a:fontRef>
+        </p:style>
+        <p:txBody>
+          <a:bodyPr rtlCol="0" anchor="ctr" wrap="square" lIns="36576" rIns="36576" tIns="18288" bIns="18288"/>
+          <a:lstStyle/>
+          <a:p>
+            <a:pPr algn="ctr">
+              <a:spcBef>
+                <a:spcPts val="0"/>
+              </a:spcBef>
+              <a:spcAft>
+                <a:spcPts val="0"/>
+              </a:spcAft>
+            </a:pPr>
+            <a:r>
+              <a:rPr sz="1300" b="1">
+                <a:solidFill>
+                  <a:srgbClr val="FFFFFF"/>
+                </a:solidFill>
+                <a:latin typeface="Microsoft YaHei"/>
+                <a:ea typeface="Microsoft YaHei"/>
+                <a:cs typeface="Microsoft YaHei"/>
+              </a:rPr>
+              <a:t>历史 1</a:t>
+            </a:r>
+          </a:p>
+        </p:txBody>
+      </p:sp>
+      <p:sp>
+        <p:nvSpPr>
+          <p:cNvPr id="19" name="Rectangle 18"/>
+          <p:cNvSpPr/>
+          <p:nvPr/>
+        </p:nvSpPr>
+        <p:spPr>
+          <a:xfrm>
+            <a:off x="4498848" y="2029968"/>
+            <a:ext cx="1700784" cy="420623"/>
+          </a:xfrm>
+          <a:prstGeom prst="rect">
+            <a:avLst/>
+          </a:prstGeom>
+          <a:solidFill>
+            <a:srgbClr val="8C6424"/>
+          </a:solidFill>
+          <a:ln>
+            <a:noFill/>
+          </a:ln>
+        </p:spPr>
+        <p:style>
+          <a:lnRef idx="1">
+            <a:schemeClr val="accent1"/>
+          </a:lnRef>
+          <a:fillRef idx="3">
+            <a:schemeClr val="accent1"/>
+          </a:fillRef>
+          <a:effectRef idx="2">
+            <a:schemeClr val="accent1"/>
+          </a:effectRef>
+          <a:fontRef idx="minor">
+            <a:schemeClr val="lt1"/>
+          </a:fontRef>
+        </p:style>
+        <p:txBody>
+          <a:bodyPr rtlCol="0" anchor="ctr" wrap="square" lIns="36576" rIns="36576" tIns="18288" bIns="18288"/>
+          <a:lstStyle/>
+          <a:p>
+            <a:pPr algn="ctr">
+              <a:spcBef>
+                <a:spcPts val="0"/>
+              </a:spcBef>
+              <a:spcAft>
+                <a:spcPts val="0"/>
+              </a:spcAft>
+            </a:pPr>
+            <a:r>
+              <a:rPr sz="1300" b="1">
+                <a:solidFill>
+                  <a:srgbClr val="FFFFFF"/>
+                </a:solidFill>
+                <a:latin typeface="Microsoft YaHei"/>
+                <a:ea typeface="Microsoft YaHei"/>
+                <a:cs typeface="Microsoft YaHei"/>
+              </a:rPr>
+              <a:t>历史 2</a:t>
+            </a:r>
+          </a:p>
+        </p:txBody>
+      </p:sp>
+      <p:sp>
+        <p:nvSpPr>
+          <p:cNvPr id="20" name="Rectangle 19"/>
+          <p:cNvSpPr/>
+          <p:nvPr/>
+        </p:nvSpPr>
+        <p:spPr>
+          <a:xfrm>
+            <a:off x="6254496" y="2029968"/>
+            <a:ext cx="1700784" cy="420623"/>
+          </a:xfrm>
+          <a:prstGeom prst="rect">
+            <a:avLst/>
+          </a:prstGeom>
+          <a:solidFill>
+            <a:srgbClr val="8C6424"/>
+          </a:solidFill>
+          <a:ln>
+            <a:noFill/>
+          </a:ln>
+        </p:spPr>
+        <p:style>
+          <a:lnRef idx="1">
+            <a:schemeClr val="accent1"/>
+          </a:lnRef>
+          <a:fillRef idx="3">
+            <a:schemeClr val="accent1"/>
+          </a:fillRef>
+          <a:effectRef idx="2">
+            <a:schemeClr val="accent1"/>
+          </a:effectRef>
+          <a:fontRef idx="minor">
+            <a:schemeClr val="lt1"/>
+          </a:fontRef>
+        </p:style>
+        <p:txBody>
+          <a:bodyPr rtlCol="0" anchor="ctr" wrap="square" lIns="36576" rIns="36576" tIns="18288" bIns="18288"/>
+          <a:lstStyle/>
+          <a:p>
+            <a:pPr algn="ctr">
+              <a:spcBef>
+                <a:spcPts val="0"/>
+              </a:spcBef>
+              <a:spcAft>
+                <a:spcPts val="0"/>
+              </a:spcAft>
+            </a:pPr>
+            <a:r>
+              <a:rPr sz="1300" b="1">
+                <a:solidFill>
+                  <a:srgbClr val="FFFFFF"/>
+                </a:solidFill>
+                <a:latin typeface="Microsoft YaHei"/>
+                <a:ea typeface="Microsoft YaHei"/>
+                <a:cs typeface="Microsoft YaHei"/>
+              </a:rPr>
+              <a:t>历史 3</a:t>
+            </a:r>
+          </a:p>
+        </p:txBody>
+      </p:sp>
+      <p:sp>
+        <p:nvSpPr>
+          <p:cNvPr id="21" name="Rectangle 20"/>
+          <p:cNvSpPr/>
+          <p:nvPr/>
+        </p:nvSpPr>
+        <p:spPr>
+          <a:xfrm>
+            <a:off x="8010144" y="2029968"/>
+            <a:ext cx="1700784" cy="420623"/>
+          </a:xfrm>
+          <a:prstGeom prst="rect">
+            <a:avLst/>
+          </a:prstGeom>
+          <a:solidFill>
+            <a:srgbClr val="8C6424"/>
+          </a:solidFill>
+          <a:ln>
+            <a:noFill/>
+          </a:ln>
+        </p:spPr>
+        <p:style>
+          <a:lnRef idx="1">
+            <a:schemeClr val="accent1"/>
+          </a:lnRef>
+          <a:fillRef idx="3">
+            <a:schemeClr val="accent1"/>
+          </a:fillRef>
+          <a:effectRef idx="2">
+            <a:schemeClr val="accent1"/>
+          </a:effectRef>
+          <a:fontRef idx="minor">
+            <a:schemeClr val="lt1"/>
+          </a:fontRef>
+        </p:style>
+        <p:txBody>
+          <a:bodyPr rtlCol="0" anchor="ctr" wrap="square" lIns="36576" rIns="36576" tIns="18288" bIns="18288"/>
+          <a:lstStyle/>
+          <a:p>
+            <a:pPr algn="ctr">
+              <a:spcBef>
+                <a:spcPts val="0"/>
+              </a:spcBef>
+              <a:spcAft>
+                <a:spcPts val="0"/>
+              </a:spcAft>
+            </a:pPr>
+            <a:r>
+              <a:rPr sz="1300" b="1">
+                <a:solidFill>
+                  <a:srgbClr val="FFFFFF"/>
+                </a:solidFill>
+                <a:latin typeface="Microsoft YaHei"/>
+                <a:ea typeface="Microsoft YaHei"/>
+                <a:cs typeface="Microsoft YaHei"/>
+              </a:rPr>
+              <a:t>历史 4</a:t>
+            </a:r>
+          </a:p>
+        </p:txBody>
+      </p:sp>
+      <p:sp>
+        <p:nvSpPr>
+          <p:cNvPr id="22" name="Rectangle 21"/>
+          <p:cNvSpPr/>
+          <p:nvPr/>
+        </p:nvSpPr>
+        <p:spPr>
+          <a:xfrm>
+            <a:off x="2743200" y="2834640"/>
+            <a:ext cx="1700784" cy="420623"/>
+          </a:xfrm>
+          <a:prstGeom prst="rect">
+            <a:avLst/>
+          </a:prstGeom>
+          <a:solidFill>
+            <a:srgbClr val="FFDCD2"/>
+          </a:solidFill>
+          <a:ln>
+            <a:noFill/>
+          </a:ln>
+        </p:spPr>
+        <p:style>
+          <a:lnRef idx="1">
+            <a:schemeClr val="accent1"/>
+          </a:lnRef>
+          <a:fillRef idx="3">
+            <a:schemeClr val="accent1"/>
+          </a:fillRef>
+          <a:effectRef idx="2">
+            <a:schemeClr val="accent1"/>
+          </a:effectRef>
+          <a:fontRef idx="minor">
+            <a:schemeClr val="lt1"/>
+          </a:fontRef>
+        </p:style>
+        <p:txBody>
+          <a:bodyPr rtlCol="0" anchor="ctr" wrap="square" lIns="36576" rIns="36576" tIns="18288" bIns="18288"/>
+          <a:lstStyle/>
+          <a:p>
+            <a:pPr algn="ctr">
+              <a:spcBef>
+                <a:spcPts val="0"/>
+              </a:spcBef>
+              <a:spcAft>
+                <a:spcPts val="0"/>
+              </a:spcAft>
+            </a:pPr>
+            <a:r>
+              <a:rPr sz="1200" b="1">
+                <a:solidFill>
+                  <a:srgbClr val="B04034"/>
+                </a:solidFill>
+                <a:latin typeface="Microsoft YaHei"/>
+                <a:ea typeface="Microsoft YaHei"/>
+                <a:cs typeface="Microsoft YaHei"/>
+              </a:rPr>
+              <a:t>等历史 1</a:t>
+            </a:r>
+          </a:p>
+        </p:txBody>
+      </p:sp>
+      <p:sp>
+        <p:nvSpPr>
+          <p:cNvPr id="23" name="Rectangle 22"/>
+          <p:cNvSpPr/>
+          <p:nvPr/>
+        </p:nvSpPr>
+        <p:spPr>
+          <a:xfrm>
+            <a:off x="4498848" y="2834640"/>
+            <a:ext cx="969264" cy="420623"/>
+          </a:xfrm>
+          <a:prstGeom prst="rect">
+            <a:avLst/>
+          </a:prstGeom>
+          <a:solidFill>
+            <a:srgbClr val="145A96"/>
+          </a:solidFill>
+          <a:ln>
+            <a:noFill/>
+          </a:ln>
+        </p:spPr>
+        <p:style>
+          <a:lnRef idx="1">
+            <a:schemeClr val="accent1"/>
+          </a:lnRef>
+          <a:fillRef idx="3">
+            <a:schemeClr val="accent1"/>
+          </a:fillRef>
+          <a:effectRef idx="2">
+            <a:schemeClr val="accent1"/>
+          </a:effectRef>
+          <a:fontRef idx="minor">
+            <a:schemeClr val="lt1"/>
+          </a:fontRef>
+        </p:style>
+        <p:txBody>
+          <a:bodyPr rtlCol="0" anchor="ctr" wrap="square" lIns="36576" rIns="36576" tIns="18288" bIns="18288"/>
+          <a:lstStyle/>
+          <a:p>
+            <a:pPr algn="ctr">
+              <a:spcBef>
+                <a:spcPts val="0"/>
+              </a:spcBef>
+              <a:spcAft>
+                <a:spcPts val="0"/>
+              </a:spcAft>
+            </a:pPr>
+            <a:r>
+              <a:rPr sz="1200" b="1">
+                <a:solidFill>
+                  <a:srgbClr val="FFFFFF"/>
+                </a:solidFill>
+                <a:latin typeface="Microsoft YaHei"/>
+                <a:ea typeface="Microsoft YaHei"/>
+                <a:cs typeface="Microsoft YaHei"/>
+              </a:rPr>
+              <a:t>重算 1</a:t>
+            </a:r>
+          </a:p>
+        </p:txBody>
+      </p:sp>
+      <p:sp>
+        <p:nvSpPr>
+          <p:cNvPr id="24" name="Rectangle 23"/>
+          <p:cNvSpPr/>
+          <p:nvPr/>
+        </p:nvSpPr>
+        <p:spPr>
+          <a:xfrm>
+            <a:off x="5522976" y="2834640"/>
+            <a:ext cx="676655" cy="420623"/>
+          </a:xfrm>
+          <a:prstGeom prst="rect">
+            <a:avLst/>
+          </a:prstGeom>
+          <a:solidFill>
+            <a:srgbClr val="FFDCD2"/>
+          </a:solidFill>
+          <a:ln>
+            <a:noFill/>
+          </a:ln>
+        </p:spPr>
+        <p:style>
+          <a:lnRef idx="1">
+            <a:schemeClr val="accent1"/>
+          </a:lnRef>
+          <a:fillRef idx="3">
+            <a:schemeClr val="accent1"/>
+          </a:fillRef>
+          <a:effectRef idx="2">
+            <a:schemeClr val="accent1"/>
+          </a:effectRef>
+          <a:fontRef idx="minor">
+            <a:schemeClr val="lt1"/>
+          </a:fontRef>
+        </p:style>
+        <p:txBody>
+          <a:bodyPr rtlCol="0" anchor="ctr" wrap="square" lIns="36576" rIns="36576" tIns="18288" bIns="18288"/>
+          <a:lstStyle/>
+          <a:p>
+            <a:pPr algn="ctr">
+              <a:spcBef>
+                <a:spcPts val="0"/>
+              </a:spcBef>
+              <a:spcAft>
+                <a:spcPts val="0"/>
+              </a:spcAft>
+            </a:pPr>
+            <a:r>
+              <a:rPr sz="1100" b="1">
+                <a:solidFill>
+                  <a:srgbClr val="B04034"/>
+                </a:solidFill>
+                <a:latin typeface="Microsoft YaHei"/>
+                <a:ea typeface="Microsoft YaHei"/>
+                <a:cs typeface="Microsoft YaHei"/>
+              </a:rPr>
+              <a:t>等</a:t>
+            </a:r>
+          </a:p>
+        </p:txBody>
+      </p:sp>
+      <p:sp>
+        <p:nvSpPr>
+          <p:cNvPr id="25" name="Rectangle 24"/>
+          <p:cNvSpPr/>
+          <p:nvPr/>
+        </p:nvSpPr>
+        <p:spPr>
+          <a:xfrm>
+            <a:off x="6254496" y="2834640"/>
+            <a:ext cx="969264" cy="420623"/>
+          </a:xfrm>
+          <a:prstGeom prst="rect">
+            <a:avLst/>
+          </a:prstGeom>
+          <a:solidFill>
+            <a:srgbClr val="145A96"/>
+          </a:solidFill>
+          <a:ln>
+            <a:noFill/>
+          </a:ln>
+        </p:spPr>
+        <p:style>
+          <a:lnRef idx="1">
+            <a:schemeClr val="accent1"/>
+          </a:lnRef>
+          <a:fillRef idx="3">
+            <a:schemeClr val="accent1"/>
+          </a:fillRef>
+          <a:effectRef idx="2">
+            <a:schemeClr val="accent1"/>
+          </a:effectRef>
+          <a:fontRef idx="minor">
+            <a:schemeClr val="lt1"/>
+          </a:fontRef>
+        </p:style>
+        <p:txBody>
+          <a:bodyPr rtlCol="0" anchor="ctr" wrap="square" lIns="36576" rIns="36576" tIns="18288" bIns="18288"/>
+          <a:lstStyle/>
+          <a:p>
+            <a:pPr algn="ctr">
+              <a:spcBef>
+                <a:spcPts val="0"/>
+              </a:spcBef>
+              <a:spcAft>
+                <a:spcPts val="0"/>
+              </a:spcAft>
+            </a:pPr>
+            <a:r>
+              <a:rPr sz="1200" b="1">
+                <a:solidFill>
+                  <a:srgbClr val="FFFFFF"/>
+                </a:solidFill>
+                <a:latin typeface="Microsoft YaHei"/>
+                <a:ea typeface="Microsoft YaHei"/>
+                <a:cs typeface="Microsoft YaHei"/>
+              </a:rPr>
+              <a:t>重算 2</a:t>
+            </a:r>
+          </a:p>
+        </p:txBody>
+      </p:sp>
+      <p:sp>
+        <p:nvSpPr>
+          <p:cNvPr id="26" name="Rectangle 25"/>
+          <p:cNvSpPr/>
+          <p:nvPr/>
+        </p:nvSpPr>
+        <p:spPr>
+          <a:xfrm>
+            <a:off x="7278624" y="2834640"/>
+            <a:ext cx="676655" cy="420623"/>
+          </a:xfrm>
+          <a:prstGeom prst="rect">
+            <a:avLst/>
+          </a:prstGeom>
+          <a:solidFill>
+            <a:srgbClr val="FFDCD2"/>
+          </a:solidFill>
+          <a:ln>
+            <a:noFill/>
+          </a:ln>
+        </p:spPr>
+        <p:style>
+          <a:lnRef idx="1">
+            <a:schemeClr val="accent1"/>
+          </a:lnRef>
+          <a:fillRef idx="3">
+            <a:schemeClr val="accent1"/>
+          </a:fillRef>
+          <a:effectRef idx="2">
+            <a:schemeClr val="accent1"/>
+          </a:effectRef>
+          <a:fontRef idx="minor">
+            <a:schemeClr val="lt1"/>
+          </a:fontRef>
+        </p:style>
+        <p:txBody>
+          <a:bodyPr rtlCol="0" anchor="ctr" wrap="square" lIns="36576" rIns="36576" tIns="18288" bIns="18288"/>
+          <a:lstStyle/>
+          <a:p>
+            <a:pPr algn="ctr">
+              <a:spcBef>
+                <a:spcPts val="0"/>
+              </a:spcBef>
+              <a:spcAft>
+                <a:spcPts val="0"/>
+              </a:spcAft>
+            </a:pPr>
+            <a:r>
+              <a:rPr sz="1100" b="1">
+                <a:solidFill>
+                  <a:srgbClr val="B04034"/>
+                </a:solidFill>
+                <a:latin typeface="Microsoft YaHei"/>
+                <a:ea typeface="Microsoft YaHei"/>
+                <a:cs typeface="Microsoft YaHei"/>
+              </a:rPr>
+              <a:t>等</a:t>
+            </a:r>
+          </a:p>
+        </p:txBody>
+      </p:sp>
+      <p:sp>
+        <p:nvSpPr>
+          <p:cNvPr id="27" name="Rectangle 26"/>
+          <p:cNvSpPr/>
+          <p:nvPr/>
+        </p:nvSpPr>
+        <p:spPr>
+          <a:xfrm>
+            <a:off x="8010144" y="2834640"/>
+            <a:ext cx="969264" cy="420623"/>
+          </a:xfrm>
+          <a:prstGeom prst="rect">
+            <a:avLst/>
+          </a:prstGeom>
+          <a:solidFill>
+            <a:srgbClr val="145A96"/>
+          </a:solidFill>
+          <a:ln>
+            <a:noFill/>
+          </a:ln>
+        </p:spPr>
+        <p:style>
+          <a:lnRef idx="1">
+            <a:schemeClr val="accent1"/>
+          </a:lnRef>
+          <a:fillRef idx="3">
+            <a:schemeClr val="accent1"/>
+          </a:fillRef>
+          <a:effectRef idx="2">
+            <a:schemeClr val="accent1"/>
+          </a:effectRef>
+          <a:fontRef idx="minor">
+            <a:schemeClr val="lt1"/>
+          </a:fontRef>
+        </p:style>
+        <p:txBody>
+          <a:bodyPr rtlCol="0" anchor="ctr" wrap="square" lIns="36576" rIns="36576" tIns="18288" bIns="18288"/>
+          <a:lstStyle/>
+          <a:p>
+            <a:pPr algn="ctr">
+              <a:spcBef>
+                <a:spcPts val="0"/>
+              </a:spcBef>
+              <a:spcAft>
+                <a:spcPts val="0"/>
+              </a:spcAft>
+            </a:pPr>
+            <a:r>
+              <a:rPr sz="1200" b="1">
+                <a:solidFill>
+                  <a:srgbClr val="FFFFFF"/>
+                </a:solidFill>
+                <a:latin typeface="Microsoft YaHei"/>
+                <a:ea typeface="Microsoft YaHei"/>
+                <a:cs typeface="Microsoft YaHei"/>
+              </a:rPr>
+              <a:t>重算 3</a:t>
+            </a:r>
+          </a:p>
+        </p:txBody>
+      </p:sp>
+      <p:sp>
+        <p:nvSpPr>
+          <p:cNvPr id="28" name="Rectangle 27"/>
+          <p:cNvSpPr/>
+          <p:nvPr/>
+        </p:nvSpPr>
+        <p:spPr>
+          <a:xfrm>
+            <a:off x="9034272" y="2834640"/>
+            <a:ext cx="676655" cy="420623"/>
+          </a:xfrm>
+          <a:prstGeom prst="rect">
+            <a:avLst/>
+          </a:prstGeom>
+          <a:solidFill>
+            <a:srgbClr val="FFDCD2"/>
+          </a:solidFill>
+          <a:ln>
+            <a:noFill/>
+          </a:ln>
+        </p:spPr>
+        <p:style>
+          <a:lnRef idx="1">
+            <a:schemeClr val="accent1"/>
+          </a:lnRef>
+          <a:fillRef idx="3">
+            <a:schemeClr val="accent1"/>
+          </a:fillRef>
+          <a:effectRef idx="2">
+            <a:schemeClr val="accent1"/>
+          </a:effectRef>
+          <a:fontRef idx="minor">
+            <a:schemeClr val="lt1"/>
+          </a:fontRef>
+        </p:style>
+        <p:txBody>
+          <a:bodyPr rtlCol="0" anchor="ctr" wrap="square" lIns="36576" rIns="36576" tIns="18288" bIns="18288"/>
+          <a:lstStyle/>
+          <a:p>
+            <a:pPr algn="ctr">
+              <a:spcBef>
+                <a:spcPts val="0"/>
+              </a:spcBef>
+              <a:spcAft>
+                <a:spcPts val="0"/>
+              </a:spcAft>
+            </a:pPr>
+            <a:r>
+              <a:rPr sz="1100" b="1">
+                <a:solidFill>
+                  <a:srgbClr val="B04034"/>
+                </a:solidFill>
+                <a:latin typeface="Microsoft YaHei"/>
+                <a:ea typeface="Microsoft YaHei"/>
+                <a:cs typeface="Microsoft YaHei"/>
+              </a:rPr>
+              <a:t>等</a:t>
+            </a:r>
+          </a:p>
+        </p:txBody>
+      </p:sp>
+      <p:sp>
+        <p:nvSpPr>
+          <p:cNvPr id="29" name="Rectangle 28"/>
+          <p:cNvSpPr/>
+          <p:nvPr/>
+        </p:nvSpPr>
+        <p:spPr>
+          <a:xfrm>
+            <a:off x="9765792" y="2834640"/>
+            <a:ext cx="969264" cy="420623"/>
+          </a:xfrm>
+          <a:prstGeom prst="rect">
+            <a:avLst/>
+          </a:prstGeom>
+          <a:solidFill>
+            <a:srgbClr val="145A96"/>
+          </a:solidFill>
+          <a:ln>
+            <a:noFill/>
+          </a:ln>
+        </p:spPr>
+        <p:style>
+          <a:lnRef idx="1">
+            <a:schemeClr val="accent1"/>
+          </a:lnRef>
+          <a:fillRef idx="3">
+            <a:schemeClr val="accent1"/>
+          </a:fillRef>
+          <a:effectRef idx="2">
+            <a:schemeClr val="accent1"/>
+          </a:effectRef>
+          <a:fontRef idx="minor">
+            <a:schemeClr val="lt1"/>
+          </a:fontRef>
+        </p:style>
+        <p:txBody>
+          <a:bodyPr rtlCol="0" anchor="ctr" wrap="square" lIns="36576" rIns="36576" tIns="18288" bIns="18288"/>
+          <a:lstStyle/>
+          <a:p>
+            <a:pPr algn="ctr">
+              <a:spcBef>
+                <a:spcPts val="0"/>
+              </a:spcBef>
+              <a:spcAft>
+                <a:spcPts val="0"/>
+              </a:spcAft>
+            </a:pPr>
+            <a:r>
+              <a:rPr sz="1200" b="1">
+                <a:solidFill>
+                  <a:srgbClr val="FFFFFF"/>
+                </a:solidFill>
+                <a:latin typeface="Microsoft YaHei"/>
+                <a:ea typeface="Microsoft YaHei"/>
+                <a:cs typeface="Microsoft YaHei"/>
+              </a:rPr>
+              <a:t>重算 4</a:t>
+            </a:r>
+          </a:p>
+        </p:txBody>
+      </p:sp>
+      <p:sp>
+        <p:nvSpPr>
+          <p:cNvPr id="30" name="Rectangle 29"/>
+          <p:cNvSpPr/>
+          <p:nvPr/>
+        </p:nvSpPr>
+        <p:spPr>
+          <a:xfrm>
+            <a:off x="10789920" y="2834640"/>
+            <a:ext cx="886968" cy="420623"/>
+          </a:xfrm>
+          <a:prstGeom prst="rect">
+            <a:avLst/>
+          </a:prstGeom>
+          <a:solidFill>
+            <a:srgbClr val="1B6E48"/>
+          </a:solidFill>
+          <a:ln>
+            <a:noFill/>
+          </a:ln>
+        </p:spPr>
+        <p:style>
+          <a:lnRef idx="1">
+            <a:schemeClr val="accent1"/>
+          </a:lnRef>
+          <a:fillRef idx="3">
+            <a:schemeClr val="accent1"/>
+          </a:fillRef>
+          <a:effectRef idx="2">
+            <a:schemeClr val="accent1"/>
+          </a:effectRef>
+          <a:fontRef idx="minor">
+            <a:schemeClr val="lt1"/>
+          </a:fontRef>
+        </p:style>
+        <p:txBody>
+          <a:bodyPr rtlCol="0" anchor="ctr" wrap="square" lIns="36576" rIns="36576" tIns="18288" bIns="18288"/>
+          <a:lstStyle/>
+          <a:p>
+            <a:pPr algn="ctr">
+              <a:spcBef>
+                <a:spcPts val="0"/>
+              </a:spcBef>
+              <a:spcAft>
+                <a:spcPts val="0"/>
+              </a:spcAft>
+            </a:pPr>
+            <a:r>
+              <a:rPr sz="1200" b="1">
+                <a:solidFill>
+                  <a:srgbClr val="FFFFFF"/>
+                </a:solidFill>
+                <a:latin typeface="Microsoft YaHei"/>
+                <a:ea typeface="Microsoft YaHei"/>
+                <a:cs typeface="Microsoft YaHei"/>
+              </a:rPr>
+              <a:t>首 token</a:t>
+            </a:r>
+          </a:p>
+        </p:txBody>
+      </p:sp>
+      <p:sp>
+        <p:nvSpPr>
+          <p:cNvPr id="31" name="Rectangle 30"/>
+          <p:cNvSpPr/>
+          <p:nvPr/>
+        </p:nvSpPr>
+        <p:spPr>
+          <a:xfrm>
+            <a:off x="10776204" y="1938528"/>
+            <a:ext cx="27432" cy="1371600"/>
+          </a:xfrm>
+          <a:prstGeom prst="rect">
+            <a:avLst/>
+          </a:prstGeom>
+          <a:solidFill>
+            <a:srgbClr val="1B6E48"/>
+          </a:solidFill>
+          <a:ln>
+            <a:noFill/>
+          </a:ln>
+        </p:spPr>
+        <p:style>
+          <a:lnRef idx="1">
+            <a:schemeClr val="accent1"/>
+          </a:lnRef>
+          <a:fillRef idx="3">
+            <a:schemeClr val="accent1"/>
+          </a:fillRef>
+          <a:effectRef idx="2">
+            <a:schemeClr val="accent1"/>
+          </a:effectRef>
+          <a:fontRef idx="minor">
+            <a:schemeClr val="lt1"/>
+          </a:fontRef>
+        </p:style>
+        <p:txBody>
+          <a:bodyPr rtlCol="0" anchor="ctr"/>
+          <a:lstStyle/>
+          <a:p>
+            <a:pPr algn="ctr"/>
+          </a:p>
+        </p:txBody>
+      </p:sp>
+      <p:sp>
+        <p:nvSpPr>
+          <p:cNvPr id="32" name="TextBox 31"/>
+          <p:cNvSpPr txBox="1"/>
+          <p:nvPr/>
+        </p:nvSpPr>
+        <p:spPr>
+          <a:xfrm>
+            <a:off x="2743200" y="2505456"/>
+            <a:ext cx="7022592" cy="274320"/>
+          </a:xfrm>
+          <a:prstGeom prst="rect">
+            <a:avLst/>
+          </a:prstGeom>
+          <a:noFill/>
+        </p:spPr>
+        <p:txBody>
+          <a:bodyPr wrap="square" lIns="0" rIns="0" tIns="0" bIns="0" anchor="ctr"/>
+          <a:lstStyle/>
+          <a:p>
+            <a:pPr algn="ctr">
+              <a:spcBef>
+                <a:spcPts val="0"/>
+              </a:spcBef>
+              <a:spcAft>
+                <a:spcPts val="0"/>
+              </a:spcAft>
+            </a:pPr>
+            <a:r>
+              <a:rPr sz="1200" b="1">
+                <a:solidFill>
+                  <a:srgbClr val="145A96"/>
+                </a:solidFill>
+                <a:latin typeface="Microsoft YaHei"/>
+                <a:ea typeface="Microsoft YaHei"/>
+                <a:cs typeface="Microsoft YaHei"/>
+              </a:rPr>
+              <a:t>依赖：该层历史 KV 到位，本地才能算这一层</a:t>
+            </a:r>
+          </a:p>
+        </p:txBody>
+      </p:sp>
+      <p:sp>
+        <p:nvSpPr>
+          <p:cNvPr id="33" name="Rectangle 32"/>
+          <p:cNvSpPr/>
+          <p:nvPr/>
+        </p:nvSpPr>
+        <p:spPr>
+          <a:xfrm>
+            <a:off x="256032" y="4315968"/>
+            <a:ext cx="3820058" cy="1783080"/>
+          </a:xfrm>
+          <a:prstGeom prst="rect">
+            <a:avLst/>
+          </a:prstGeom>
+          <a:solidFill>
+            <a:srgbClr val="FFFFFF"/>
+          </a:solidFill>
+          <a:ln w="9525">
+            <a:solidFill>
+              <a:srgbClr val="D6DCE2"/>
+            </a:solidFill>
+          </a:ln>
+        </p:spPr>
+        <p:style>
+          <a:lnRef idx="1">
+            <a:schemeClr val="accent1"/>
+          </a:lnRef>
+          <a:fillRef idx="3">
+            <a:schemeClr val="accent1"/>
+          </a:fillRef>
+          <a:effectRef idx="2">
+            <a:schemeClr val="accent1"/>
+          </a:effectRef>
+          <a:fontRef idx="minor">
+            <a:schemeClr val="lt1"/>
+          </a:fontRef>
+        </p:style>
+        <p:txBody>
+          <a:bodyPr rtlCol="0" anchor="ctr"/>
+          <a:lstStyle/>
+          <a:p>
+            <a:pPr algn="ctr"/>
+          </a:p>
+        </p:txBody>
+      </p:sp>
+      <p:sp>
+        <p:nvSpPr>
+          <p:cNvPr id="34" name="Rectangle 33"/>
+          <p:cNvSpPr/>
+          <p:nvPr/>
+        </p:nvSpPr>
+        <p:spPr>
+          <a:xfrm>
+            <a:off x="256032" y="4315968"/>
+            <a:ext cx="73152" cy="1783080"/>
+          </a:xfrm>
+          <a:prstGeom prst="rect">
+            <a:avLst/>
+          </a:prstGeom>
+          <a:solidFill>
+            <a:srgbClr val="0E7A76"/>
+          </a:solidFill>
+          <a:ln>
+            <a:noFill/>
+          </a:ln>
+        </p:spPr>
+        <p:style>
+          <a:lnRef idx="1">
+            <a:schemeClr val="accent1"/>
+          </a:lnRef>
+          <a:fillRef idx="3">
+            <a:schemeClr val="accent1"/>
+          </a:fillRef>
+          <a:effectRef idx="2">
+            <a:schemeClr val="accent1"/>
+          </a:effectRef>
+          <a:fontRef idx="minor">
+            <a:schemeClr val="lt1"/>
+          </a:fontRef>
+        </p:style>
+        <p:txBody>
+          <a:bodyPr rtlCol="0" anchor="ctr"/>
+          <a:lstStyle/>
+          <a:p>
+            <a:pPr algn="ctr"/>
+          </a:p>
+        </p:txBody>
+      </p:sp>
+      <p:sp>
+        <p:nvSpPr>
+          <p:cNvPr id="35" name="TextBox 34"/>
+          <p:cNvSpPr txBox="1"/>
+          <p:nvPr/>
+        </p:nvSpPr>
+        <p:spPr>
+          <a:xfrm>
+            <a:off x="420624" y="4407407"/>
+            <a:ext cx="3545738" cy="274320"/>
+          </a:xfrm>
+          <a:prstGeom prst="rect">
+            <a:avLst/>
+          </a:prstGeom>
+          <a:noFill/>
+        </p:spPr>
+        <p:txBody>
+          <a:bodyPr wrap="square" lIns="0" rIns="0" tIns="0" bIns="0" anchor="ctr"/>
+          <a:lstStyle/>
+          <a:p>
+            <a:pPr algn="l">
+              <a:spcBef>
+                <a:spcPts val="0"/>
+              </a:spcBef>
+              <a:spcAft>
+                <a:spcPts val="0"/>
+              </a:spcAft>
+            </a:pPr>
+            <a:r>
+              <a:rPr sz="1400" b="1">
+                <a:solidFill>
+                  <a:srgbClr val="0E7A76"/>
+                </a:solidFill>
+                <a:latin typeface="Microsoft YaHei"/>
+                <a:ea typeface="Microsoft YaHei"/>
+                <a:cs typeface="Microsoft YaHei"/>
+              </a:rPr>
+              <a:t>被盖住</a:t>
+            </a:r>
+          </a:p>
+        </p:txBody>
+      </p:sp>
+      <p:sp>
+        <p:nvSpPr>
+          <p:cNvPr id="36" name="TextBox 35"/>
+          <p:cNvSpPr txBox="1"/>
+          <p:nvPr/>
+        </p:nvSpPr>
+        <p:spPr>
+          <a:xfrm>
+            <a:off x="420624" y="4718304"/>
+            <a:ext cx="3545738" cy="1280160"/>
+          </a:xfrm>
+          <a:prstGeom prst="rect">
+            <a:avLst/>
+          </a:prstGeom>
+          <a:noFill/>
+        </p:spPr>
+        <p:txBody>
+          <a:bodyPr wrap="square" lIns="0" rIns="0" tIns="0" bIns="0" anchor="t"/>
+          <a:lstStyle/>
+          <a:p>
+            <a:pPr algn="l">
+              <a:spcBef>
+                <a:spcPts val="0"/>
+              </a:spcBef>
+              <a:spcAft>
+                <a:spcPts val="0"/>
+              </a:spcAft>
+            </a:pPr>
+            <a:r>
+              <a:rPr sz="1300" b="0">
+                <a:solidFill>
+                  <a:srgbClr val="1C242E"/>
+                </a:solidFill>
+                <a:latin typeface="Microsoft YaHei"/>
+                <a:ea typeface="Microsoft YaHei"/>
+                <a:cs typeface="Microsoft YaHei"/>
+              </a:rPr>
+              <a:t>历史 2 到历史 4 的读取，落在上一层本地重计算的时间里。重算 1 与历史 2 同时进行，重算 2 与历史 3 同时进行。</a:t>
+            </a:r>
+          </a:p>
+        </p:txBody>
+      </p:sp>
+      <p:sp>
+        <p:nvSpPr>
+          <p:cNvPr id="37" name="Rectangle 36"/>
+          <p:cNvSpPr/>
+          <p:nvPr/>
+        </p:nvSpPr>
+        <p:spPr>
+          <a:xfrm>
+            <a:off x="4185818" y="4315968"/>
+            <a:ext cx="3820058" cy="1783080"/>
+          </a:xfrm>
+          <a:prstGeom prst="rect">
+            <a:avLst/>
+          </a:prstGeom>
+          <a:solidFill>
+            <a:srgbClr val="FFFFFF"/>
+          </a:solidFill>
+          <a:ln w="9525">
+            <a:solidFill>
+              <a:srgbClr val="D6DCE2"/>
+            </a:solidFill>
+          </a:ln>
+        </p:spPr>
+        <p:style>
+          <a:lnRef idx="1">
+            <a:schemeClr val="accent1"/>
+          </a:lnRef>
+          <a:fillRef idx="3">
+            <a:schemeClr val="accent1"/>
+          </a:fillRef>
+          <a:effectRef idx="2">
+            <a:schemeClr val="accent1"/>
+          </a:effectRef>
+          <a:fontRef idx="minor">
+            <a:schemeClr val="lt1"/>
+          </a:fontRef>
+        </p:style>
+        <p:txBody>
+          <a:bodyPr rtlCol="0" anchor="ctr"/>
+          <a:lstStyle/>
+          <a:p>
+            <a:pPr algn="ctr"/>
+          </a:p>
+        </p:txBody>
+      </p:sp>
+      <p:sp>
+        <p:nvSpPr>
+          <p:cNvPr id="38" name="Rectangle 37"/>
+          <p:cNvSpPr/>
+          <p:nvPr/>
+        </p:nvSpPr>
+        <p:spPr>
+          <a:xfrm>
+            <a:off x="4185818" y="4315968"/>
+            <a:ext cx="73152" cy="1783080"/>
+          </a:xfrm>
+          <a:prstGeom prst="rect">
+            <a:avLst/>
+          </a:prstGeom>
+          <a:solidFill>
+            <a:srgbClr val="B04034"/>
+          </a:solidFill>
+          <a:ln>
+            <a:noFill/>
+          </a:ln>
+        </p:spPr>
+        <p:style>
+          <a:lnRef idx="1">
+            <a:schemeClr val="accent1"/>
+          </a:lnRef>
+          <a:fillRef idx="3">
+            <a:schemeClr val="accent1"/>
+          </a:fillRef>
+          <a:effectRef idx="2">
+            <a:schemeClr val="accent1"/>
+          </a:effectRef>
+          <a:fontRef idx="minor">
+            <a:schemeClr val="lt1"/>
+          </a:fontRef>
+        </p:style>
+        <p:txBody>
+          <a:bodyPr rtlCol="0" anchor="ctr"/>
+          <a:lstStyle/>
+          <a:p>
+            <a:pPr algn="ctr"/>
+          </a:p>
+        </p:txBody>
+      </p:sp>
+      <p:sp>
+        <p:nvSpPr>
+          <p:cNvPr id="39" name="TextBox 38"/>
+          <p:cNvSpPr txBox="1"/>
+          <p:nvPr/>
+        </p:nvSpPr>
+        <p:spPr>
+          <a:xfrm>
+            <a:off x="4350410" y="4407407"/>
+            <a:ext cx="3545738" cy="274320"/>
+          </a:xfrm>
+          <a:prstGeom prst="rect">
+            <a:avLst/>
+          </a:prstGeom>
+          <a:noFill/>
+        </p:spPr>
+        <p:txBody>
+          <a:bodyPr wrap="square" lIns="0" rIns="0" tIns="0" bIns="0" anchor="ctr"/>
+          <a:lstStyle/>
+          <a:p>
+            <a:pPr algn="l">
+              <a:spcBef>
+                <a:spcPts val="0"/>
+              </a:spcBef>
+              <a:spcAft>
+                <a:spcPts val="0"/>
+              </a:spcAft>
+            </a:pPr>
+            <a:r>
+              <a:rPr sz="1400" b="1">
+                <a:solidFill>
+                  <a:srgbClr val="B04034"/>
+                </a:solidFill>
+                <a:latin typeface="Microsoft YaHei"/>
+                <a:ea typeface="Microsoft YaHei"/>
+                <a:cs typeface="Microsoft YaHei"/>
+              </a:rPr>
+              <a:t>露出，可优化</a:t>
+            </a:r>
+          </a:p>
+        </p:txBody>
+      </p:sp>
+      <p:sp>
+        <p:nvSpPr>
+          <p:cNvPr id="40" name="TextBox 39"/>
+          <p:cNvSpPr txBox="1"/>
+          <p:nvPr/>
+        </p:nvSpPr>
+        <p:spPr>
+          <a:xfrm>
+            <a:off x="4350410" y="4718304"/>
+            <a:ext cx="3545738" cy="1280160"/>
+          </a:xfrm>
+          <a:prstGeom prst="rect">
+            <a:avLst/>
+          </a:prstGeom>
+          <a:noFill/>
+        </p:spPr>
+        <p:txBody>
+          <a:bodyPr wrap="square" lIns="0" rIns="0" tIns="0" bIns="0" anchor="t"/>
+          <a:lstStyle/>
+          <a:p>
+            <a:pPr algn="l">
+              <a:spcBef>
+                <a:spcPts val="0"/>
+              </a:spcBef>
+              <a:spcAft>
+                <a:spcPts val="0"/>
+              </a:spcAft>
+            </a:pPr>
+            <a:r>
+              <a:rPr sz="1300" b="0">
+                <a:solidFill>
+                  <a:srgbClr val="1C242E"/>
+                </a:solidFill>
+                <a:latin typeface="Microsoft YaHei"/>
+                <a:ea typeface="Microsoft YaHei"/>
+                <a:cs typeface="Microsoft YaHei"/>
+              </a:rPr>
+              <a:t>本地一层已经算完，下一层历史 KV 还没到，中间就是等待。池带宽变低、历史段变长，等待变长。更便宜的一小段改在本地重算，可以把等待拿掉。</a:t>
+            </a:r>
+          </a:p>
+        </p:txBody>
+      </p:sp>
+      <p:sp>
+        <p:nvSpPr>
+          <p:cNvPr id="41" name="Rectangle 40"/>
+          <p:cNvSpPr/>
+          <p:nvPr/>
+        </p:nvSpPr>
+        <p:spPr>
+          <a:xfrm>
+            <a:off x="8115604" y="4315968"/>
+            <a:ext cx="3820058" cy="1783080"/>
+          </a:xfrm>
+          <a:prstGeom prst="rect">
+            <a:avLst/>
+          </a:prstGeom>
+          <a:solidFill>
+            <a:srgbClr val="FFFFFF"/>
+          </a:solidFill>
+          <a:ln w="9525">
+            <a:solidFill>
+              <a:srgbClr val="D6DCE2"/>
+            </a:solidFill>
+          </a:ln>
+        </p:spPr>
+        <p:style>
+          <a:lnRef idx="1">
+            <a:schemeClr val="accent1"/>
+          </a:lnRef>
+          <a:fillRef idx="3">
+            <a:schemeClr val="accent1"/>
+          </a:fillRef>
+          <a:effectRef idx="2">
+            <a:schemeClr val="accent1"/>
+          </a:effectRef>
+          <a:fontRef idx="minor">
+            <a:schemeClr val="lt1"/>
+          </a:fontRef>
+        </p:style>
+        <p:txBody>
+          <a:bodyPr rtlCol="0" anchor="ctr"/>
+          <a:lstStyle/>
+          <a:p>
+            <a:pPr algn="ctr"/>
+          </a:p>
+        </p:txBody>
+      </p:sp>
+      <p:sp>
+        <p:nvSpPr>
+          <p:cNvPr id="42" name="Rectangle 41"/>
+          <p:cNvSpPr/>
+          <p:nvPr/>
+        </p:nvSpPr>
+        <p:spPr>
+          <a:xfrm>
+            <a:off x="8115604" y="4315968"/>
+            <a:ext cx="73152" cy="1783080"/>
+          </a:xfrm>
+          <a:prstGeom prst="rect">
+            <a:avLst/>
+          </a:prstGeom>
+          <a:solidFill>
+            <a:srgbClr val="1B6E48"/>
+          </a:solidFill>
+          <a:ln>
+            <a:noFill/>
+          </a:ln>
+        </p:spPr>
+        <p:style>
+          <a:lnRef idx="1">
+            <a:schemeClr val="accent1"/>
+          </a:lnRef>
+          <a:fillRef idx="3">
+            <a:schemeClr val="accent1"/>
+          </a:fillRef>
+          <a:effectRef idx="2">
+            <a:schemeClr val="accent1"/>
+          </a:effectRef>
+          <a:fontRef idx="minor">
+            <a:schemeClr val="lt1"/>
+          </a:fontRef>
+        </p:style>
+        <p:txBody>
+          <a:bodyPr rtlCol="0" anchor="ctr"/>
+          <a:lstStyle/>
+          <a:p>
+            <a:pPr algn="ctr"/>
+          </a:p>
+        </p:txBody>
+      </p:sp>
+      <p:sp>
+        <p:nvSpPr>
+          <p:cNvPr id="43" name="TextBox 42"/>
+          <p:cNvSpPr txBox="1"/>
+          <p:nvPr/>
+        </p:nvSpPr>
+        <p:spPr>
+          <a:xfrm>
+            <a:off x="8280196" y="4407407"/>
+            <a:ext cx="3545738" cy="274320"/>
+          </a:xfrm>
+          <a:prstGeom prst="rect">
+            <a:avLst/>
+          </a:prstGeom>
+          <a:noFill/>
+        </p:spPr>
+        <p:txBody>
+          <a:bodyPr wrap="square" lIns="0" rIns="0" tIns="0" bIns="0" anchor="ctr"/>
+          <a:lstStyle/>
+          <a:p>
+            <a:pPr algn="l">
+              <a:spcBef>
+                <a:spcPts val="0"/>
+              </a:spcBef>
+              <a:spcAft>
+                <a:spcPts val="0"/>
+              </a:spcAft>
+            </a:pPr>
+            <a:r>
+              <a:rPr sz="1400" b="1">
+                <a:solidFill>
+                  <a:srgbClr val="1B6E48"/>
+                </a:solidFill>
+                <a:latin typeface="Microsoft YaHei"/>
+                <a:ea typeface="Microsoft YaHei"/>
+                <a:cs typeface="Microsoft YaHei"/>
+              </a:rPr>
+              <a:t>露出落在 TTFT</a:t>
+            </a:r>
+          </a:p>
+        </p:txBody>
+      </p:sp>
+      <p:sp>
+        <p:nvSpPr>
+          <p:cNvPr id="44" name="TextBox 43"/>
+          <p:cNvSpPr txBox="1"/>
+          <p:nvPr/>
+        </p:nvSpPr>
+        <p:spPr>
+          <a:xfrm>
+            <a:off x="8280196" y="4718304"/>
+            <a:ext cx="3545738" cy="1280160"/>
+          </a:xfrm>
+          <a:prstGeom prst="rect">
+            <a:avLst/>
+          </a:prstGeom>
+          <a:noFill/>
+        </p:spPr>
+        <p:txBody>
+          <a:bodyPr wrap="square" lIns="0" rIns="0" tIns="0" bIns="0" anchor="t"/>
+          <a:lstStyle/>
+          <a:p>
+            <a:pPr algn="l">
+              <a:spcBef>
+                <a:spcPts val="0"/>
+              </a:spcBef>
+              <a:spcAft>
+                <a:spcPts val="0"/>
+              </a:spcAft>
+            </a:pPr>
+            <a:r>
+              <a:rPr sz="1300" b="0">
+                <a:solidFill>
+                  <a:srgbClr val="1C242E"/>
+                </a:solidFill>
+                <a:latin typeface="Microsoft YaHei"/>
+                <a:ea typeface="Microsoft YaHei"/>
+                <a:cs typeface="Microsoft YaHei"/>
+              </a:rPr>
+              <a:t>汇合在首 token 之前，等待直接进入 TTFT。上一页的露出在首 token 和第 2 token 之间，这一页的露出在首 token 之前。</a:t>
+            </a:r>
+          </a:p>
+        </p:txBody>
+      </p:sp>
+      <p:sp>
+        <p:nvSpPr>
+          <p:cNvPr id="45" name="TextBox 44"/>
+          <p:cNvSpPr txBox="1"/>
+          <p:nvPr/>
+        </p:nvSpPr>
+        <p:spPr>
+          <a:xfrm>
+            <a:off x="256032" y="6263640"/>
+            <a:ext cx="11612880" cy="438912"/>
+          </a:xfrm>
+          <a:prstGeom prst="rect">
+            <a:avLst/>
+          </a:prstGeom>
+          <a:noFill/>
+        </p:spPr>
+        <p:txBody>
+          <a:bodyPr wrap="square" lIns="0" rIns="0" tIns="0" bIns="0" anchor="t"/>
+          <a:lstStyle/>
+          <a:p>
+            <a:pPr algn="l">
+              <a:spcBef>
+                <a:spcPts val="0"/>
+              </a:spcBef>
+              <a:spcAft>
+                <a:spcPts val="0"/>
+              </a:spcAft>
+            </a:pPr>
+            <a:r>
+              <a:rPr sz="1200" b="0">
+                <a:solidFill>
+                  <a:srgbClr val="5A636E"/>
+                </a:solidFill>
+                <a:latin typeface="Microsoft YaHei"/>
+                <a:ea typeface="Microsoft YaHei"/>
+                <a:cs typeface="Microsoft YaHei"/>
+              </a:rPr>
+              <a:t>层间等待 = max(0, 该层历史 KV 读完的时刻 - 上一层本地算完的时刻)。</a:t>
+            </a:r>
+          </a:p>
+          <a:p>
+            <a:pPr algn="l">
+              <a:spcBef>
+                <a:spcPts val="0"/>
+              </a:spcBef>
+              <a:spcAft>
+                <a:spcPts val="0"/>
+              </a:spcAft>
+            </a:pPr>
+            <a:r>
+              <a:rPr sz="1200" b="0">
+                <a:solidFill>
+                  <a:srgbClr val="5A636E"/>
+                </a:solidFill>
+                <a:latin typeface="Microsoft YaHei"/>
+                <a:ea typeface="Microsoft YaHei"/>
+                <a:cs typeface="Microsoft YaHei"/>
+              </a:rPr>
+              <a:t>图按每层读取长于每层重计算来画，所以层与层之间有等待；读取更快时，这些等待消失，prefill 时间等于首层读取加上各层本地计算。</a:t>
             </a:r>
           </a:p>
         </p:txBody>

</xml_diff>

<commit_message>
docs: pair each KV block with the layer that consumes it
Same color and the same index mark one layer. A bridge runs from the end of layer i KV to the start of that layer's local compute, while the vertical alignment stays the same moment.

Co-authored-by: 69515164-rgb <69515164-rgb@users.noreply.github.com>
</commit_message>
<xml_diff>
--- a/docs/kv-handoff-timeline.pptx
+++ b/docs/kv-handoff-timeline.pptx
@@ -6249,7 +6249,7 @@
                 <a:ea typeface="Microsoft YaHei"/>
                 <a:cs typeface="Microsoft YaHei"/>
               </a:rPr>
-              <a:t>时间  →    读历史可与上一层本地计算重叠</a:t>
+              <a:t>同色、同编号 = 同一层。算层 i 的同时，正在读层 i+1 的 KV</a:t>
             </a:r>
           </a:p>
         </p:txBody>
@@ -6498,7 +6498,7 @@
             <a:avLst/>
           </a:prstGeom>
           <a:solidFill>
-            <a:srgbClr val="8C6424"/>
+            <a:srgbClr val="145A96"/>
           </a:solidFill>
           <a:ln>
             <a:noFill/>
@@ -6539,7 +6539,7 @@
                 <a:ea typeface="Microsoft YaHei"/>
                 <a:cs typeface="Microsoft YaHei"/>
               </a:rPr>
-              <a:t>历史 1</a:t>
+              <a:t>层1 KV</a:t>
             </a:r>
           </a:p>
         </p:txBody>
@@ -6559,7 +6559,7 @@
             <a:avLst/>
           </a:prstGeom>
           <a:solidFill>
-            <a:srgbClr val="8C6424"/>
+            <a:srgbClr val="0E6E6A"/>
           </a:solidFill>
           <a:ln>
             <a:noFill/>
@@ -6600,7 +6600,7 @@
                 <a:ea typeface="Microsoft YaHei"/>
                 <a:cs typeface="Microsoft YaHei"/>
               </a:rPr>
-              <a:t>历史 2</a:t>
+              <a:t>层2 KV</a:t>
             </a:r>
           </a:p>
         </p:txBody>
@@ -6620,7 +6620,7 @@
             <a:avLst/>
           </a:prstGeom>
           <a:solidFill>
-            <a:srgbClr val="8C6424"/>
+            <a:srgbClr val="7A541C"/>
           </a:solidFill>
           <a:ln>
             <a:noFill/>
@@ -6661,7 +6661,7 @@
                 <a:ea typeface="Microsoft YaHei"/>
                 <a:cs typeface="Microsoft YaHei"/>
               </a:rPr>
-              <a:t>历史 3</a:t>
+              <a:t>层3 KV</a:t>
             </a:r>
           </a:p>
         </p:txBody>
@@ -6681,7 +6681,7 @@
             <a:avLst/>
           </a:prstGeom>
           <a:solidFill>
-            <a:srgbClr val="8C6424"/>
+            <a:srgbClr val="583E82"/>
           </a:solidFill>
           <a:ln>
             <a:noFill/>
@@ -6722,7 +6722,7 @@
                 <a:ea typeface="Microsoft YaHei"/>
                 <a:cs typeface="Microsoft YaHei"/>
               </a:rPr>
-              <a:t>历史 4</a:t>
+              <a:t>层4 KV</a:t>
             </a:r>
           </a:p>
         </p:txBody>
@@ -6783,7 +6783,7 @@
                 <a:ea typeface="Microsoft YaHei"/>
                 <a:cs typeface="Microsoft YaHei"/>
               </a:rPr>
-              <a:t>等历史 1</a:t>
+              <a:t>等层1 KV</a:t>
             </a:r>
           </a:p>
         </p:txBody>
@@ -6844,7 +6844,7 @@
                 <a:ea typeface="Microsoft YaHei"/>
                 <a:cs typeface="Microsoft YaHei"/>
               </a:rPr>
-              <a:t>重算 1</a:t>
+              <a:t>算层1</a:t>
             </a:r>
           </a:p>
         </p:txBody>
@@ -6852,6 +6852,49 @@
       <p:sp>
         <p:nvSpPr>
           <p:cNvPr id="24" name="Rectangle 23"/>
+          <p:cNvSpPr/>
+          <p:nvPr/>
+        </p:nvSpPr>
+        <p:spPr>
+          <a:xfrm>
+            <a:off x="4425696" y="2423160"/>
+            <a:ext cx="100583" cy="438911"/>
+          </a:xfrm>
+          <a:prstGeom prst="rect">
+            <a:avLst/>
+          </a:prstGeom>
+          <a:solidFill>
+            <a:srgbClr val="145A96"/>
+          </a:solidFill>
+          <a:ln>
+            <a:noFill/>
+          </a:ln>
+        </p:spPr>
+        <p:style>
+          <a:lnRef idx="1">
+            <a:schemeClr val="accent1"/>
+          </a:lnRef>
+          <a:fillRef idx="3">
+            <a:schemeClr val="accent1"/>
+          </a:fillRef>
+          <a:effectRef idx="2">
+            <a:schemeClr val="accent1"/>
+          </a:effectRef>
+          <a:fontRef idx="minor">
+            <a:schemeClr val="lt1"/>
+          </a:fontRef>
+        </p:style>
+        <p:txBody>
+          <a:bodyPr rtlCol="0" anchor="ctr"/>
+          <a:lstStyle/>
+          <a:p>
+            <a:pPr algn="ctr"/>
+          </a:p>
+        </p:txBody>
+      </p:sp>
+      <p:sp>
+        <p:nvSpPr>
+          <p:cNvPr id="25" name="Rectangle 24"/>
           <p:cNvSpPr/>
           <p:nvPr/>
         </p:nvSpPr>
@@ -6897,7 +6940,7 @@
               </a:spcAft>
             </a:pPr>
             <a:r>
-              <a:rPr sz="1100" b="1">
+              <a:rPr sz="1000" b="1">
                 <a:solidFill>
                   <a:srgbClr val="B04034"/>
                 </a:solidFill>
@@ -6905,14 +6948,14 @@
                 <a:ea typeface="Microsoft YaHei"/>
                 <a:cs typeface="Microsoft YaHei"/>
               </a:rPr>
-              <a:t>等</a:t>
-            </a:r>
-          </a:p>
-        </p:txBody>
-      </p:sp>
-      <p:sp>
-        <p:nvSpPr>
-          <p:cNvPr id="25" name="Rectangle 24"/>
+              <a:t>等层2</a:t>
+            </a:r>
+          </a:p>
+        </p:txBody>
+      </p:sp>
+      <p:sp>
+        <p:nvSpPr>
+          <p:cNvPr id="26" name="Rectangle 25"/>
           <p:cNvSpPr/>
           <p:nvPr/>
         </p:nvSpPr>
@@ -6925,7 +6968,7 @@
             <a:avLst/>
           </a:prstGeom>
           <a:solidFill>
-            <a:srgbClr val="145A96"/>
+            <a:srgbClr val="0E6E6A"/>
           </a:solidFill>
           <a:ln>
             <a:noFill/>
@@ -6966,14 +7009,57 @@
                 <a:ea typeface="Microsoft YaHei"/>
                 <a:cs typeface="Microsoft YaHei"/>
               </a:rPr>
-              <a:t>重算 2</a:t>
-            </a:r>
-          </a:p>
-        </p:txBody>
-      </p:sp>
-      <p:sp>
-        <p:nvSpPr>
-          <p:cNvPr id="26" name="Rectangle 25"/>
+              <a:t>算层2</a:t>
+            </a:r>
+          </a:p>
+        </p:txBody>
+      </p:sp>
+      <p:sp>
+        <p:nvSpPr>
+          <p:cNvPr id="27" name="Rectangle 26"/>
+          <p:cNvSpPr/>
+          <p:nvPr/>
+        </p:nvSpPr>
+        <p:spPr>
+          <a:xfrm>
+            <a:off x="6181344" y="2423160"/>
+            <a:ext cx="100583" cy="438911"/>
+          </a:xfrm>
+          <a:prstGeom prst="rect">
+            <a:avLst/>
+          </a:prstGeom>
+          <a:solidFill>
+            <a:srgbClr val="0E6E6A"/>
+          </a:solidFill>
+          <a:ln>
+            <a:noFill/>
+          </a:ln>
+        </p:spPr>
+        <p:style>
+          <a:lnRef idx="1">
+            <a:schemeClr val="accent1"/>
+          </a:lnRef>
+          <a:fillRef idx="3">
+            <a:schemeClr val="accent1"/>
+          </a:fillRef>
+          <a:effectRef idx="2">
+            <a:schemeClr val="accent1"/>
+          </a:effectRef>
+          <a:fontRef idx="minor">
+            <a:schemeClr val="lt1"/>
+          </a:fontRef>
+        </p:style>
+        <p:txBody>
+          <a:bodyPr rtlCol="0" anchor="ctr"/>
+          <a:lstStyle/>
+          <a:p>
+            <a:pPr algn="ctr"/>
+          </a:p>
+        </p:txBody>
+      </p:sp>
+      <p:sp>
+        <p:nvSpPr>
+          <p:cNvPr id="28" name="Rectangle 27"/>
           <p:cNvSpPr/>
           <p:nvPr/>
         </p:nvSpPr>
@@ -7019,7 +7105,7 @@
               </a:spcAft>
             </a:pPr>
             <a:r>
-              <a:rPr sz="1100" b="1">
+              <a:rPr sz="1000" b="1">
                 <a:solidFill>
                   <a:srgbClr val="B04034"/>
                 </a:solidFill>
@@ -7027,14 +7113,14 @@
                 <a:ea typeface="Microsoft YaHei"/>
                 <a:cs typeface="Microsoft YaHei"/>
               </a:rPr>
-              <a:t>等</a:t>
-            </a:r>
-          </a:p>
-        </p:txBody>
-      </p:sp>
-      <p:sp>
-        <p:nvSpPr>
-          <p:cNvPr id="27" name="Rectangle 26"/>
+              <a:t>等层3</a:t>
+            </a:r>
+          </a:p>
+        </p:txBody>
+      </p:sp>
+      <p:sp>
+        <p:nvSpPr>
+          <p:cNvPr id="29" name="Rectangle 28"/>
           <p:cNvSpPr/>
           <p:nvPr/>
         </p:nvSpPr>
@@ -7047,7 +7133,7 @@
             <a:avLst/>
           </a:prstGeom>
           <a:solidFill>
-            <a:srgbClr val="145A96"/>
+            <a:srgbClr val="7A541C"/>
           </a:solidFill>
           <a:ln>
             <a:noFill/>
@@ -7088,14 +7174,57 @@
                 <a:ea typeface="Microsoft YaHei"/>
                 <a:cs typeface="Microsoft YaHei"/>
               </a:rPr>
-              <a:t>重算 3</a:t>
-            </a:r>
-          </a:p>
-        </p:txBody>
-      </p:sp>
-      <p:sp>
-        <p:nvSpPr>
-          <p:cNvPr id="28" name="Rectangle 27"/>
+              <a:t>算层3</a:t>
+            </a:r>
+          </a:p>
+        </p:txBody>
+      </p:sp>
+      <p:sp>
+        <p:nvSpPr>
+          <p:cNvPr id="30" name="Rectangle 29"/>
+          <p:cNvSpPr/>
+          <p:nvPr/>
+        </p:nvSpPr>
+        <p:spPr>
+          <a:xfrm>
+            <a:off x="7936992" y="2423160"/>
+            <a:ext cx="100583" cy="438911"/>
+          </a:xfrm>
+          <a:prstGeom prst="rect">
+            <a:avLst/>
+          </a:prstGeom>
+          <a:solidFill>
+            <a:srgbClr val="7A541C"/>
+          </a:solidFill>
+          <a:ln>
+            <a:noFill/>
+          </a:ln>
+        </p:spPr>
+        <p:style>
+          <a:lnRef idx="1">
+            <a:schemeClr val="accent1"/>
+          </a:lnRef>
+          <a:fillRef idx="3">
+            <a:schemeClr val="accent1"/>
+          </a:fillRef>
+          <a:effectRef idx="2">
+            <a:schemeClr val="accent1"/>
+          </a:effectRef>
+          <a:fontRef idx="minor">
+            <a:schemeClr val="lt1"/>
+          </a:fontRef>
+        </p:style>
+        <p:txBody>
+          <a:bodyPr rtlCol="0" anchor="ctr"/>
+          <a:lstStyle/>
+          <a:p>
+            <a:pPr algn="ctr"/>
+          </a:p>
+        </p:txBody>
+      </p:sp>
+      <p:sp>
+        <p:nvSpPr>
+          <p:cNvPr id="31" name="Rectangle 30"/>
           <p:cNvSpPr/>
           <p:nvPr/>
         </p:nvSpPr>
@@ -7141,7 +7270,7 @@
               </a:spcAft>
             </a:pPr>
             <a:r>
-              <a:rPr sz="1100" b="1">
+              <a:rPr sz="1000" b="1">
                 <a:solidFill>
                   <a:srgbClr val="B04034"/>
                 </a:solidFill>
@@ -7149,14 +7278,14 @@
                 <a:ea typeface="Microsoft YaHei"/>
                 <a:cs typeface="Microsoft YaHei"/>
               </a:rPr>
-              <a:t>等</a:t>
-            </a:r>
-          </a:p>
-        </p:txBody>
-      </p:sp>
-      <p:sp>
-        <p:nvSpPr>
-          <p:cNvPr id="29" name="Rectangle 28"/>
+              <a:t>等层4</a:t>
+            </a:r>
+          </a:p>
+        </p:txBody>
+      </p:sp>
+      <p:sp>
+        <p:nvSpPr>
+          <p:cNvPr id="32" name="Rectangle 31"/>
           <p:cNvSpPr/>
           <p:nvPr/>
         </p:nvSpPr>
@@ -7169,7 +7298,7 @@
             <a:avLst/>
           </a:prstGeom>
           <a:solidFill>
-            <a:srgbClr val="145A96"/>
+            <a:srgbClr val="583E82"/>
           </a:solidFill>
           <a:ln>
             <a:noFill/>
@@ -7210,14 +7339,57 @@
                 <a:ea typeface="Microsoft YaHei"/>
                 <a:cs typeface="Microsoft YaHei"/>
               </a:rPr>
-              <a:t>重算 4</a:t>
-            </a:r>
-          </a:p>
-        </p:txBody>
-      </p:sp>
-      <p:sp>
-        <p:nvSpPr>
-          <p:cNvPr id="30" name="Rectangle 29"/>
+              <a:t>算层4</a:t>
+            </a:r>
+          </a:p>
+        </p:txBody>
+      </p:sp>
+      <p:sp>
+        <p:nvSpPr>
+          <p:cNvPr id="33" name="Rectangle 32"/>
+          <p:cNvSpPr/>
+          <p:nvPr/>
+        </p:nvSpPr>
+        <p:spPr>
+          <a:xfrm>
+            <a:off x="9692640" y="2423160"/>
+            <a:ext cx="100583" cy="438911"/>
+          </a:xfrm>
+          <a:prstGeom prst="rect">
+            <a:avLst/>
+          </a:prstGeom>
+          <a:solidFill>
+            <a:srgbClr val="583E82"/>
+          </a:solidFill>
+          <a:ln>
+            <a:noFill/>
+          </a:ln>
+        </p:spPr>
+        <p:style>
+          <a:lnRef idx="1">
+            <a:schemeClr val="accent1"/>
+          </a:lnRef>
+          <a:fillRef idx="3">
+            <a:schemeClr val="accent1"/>
+          </a:fillRef>
+          <a:effectRef idx="2">
+            <a:schemeClr val="accent1"/>
+          </a:effectRef>
+          <a:fontRef idx="minor">
+            <a:schemeClr val="lt1"/>
+          </a:fontRef>
+        </p:style>
+        <p:txBody>
+          <a:bodyPr rtlCol="0" anchor="ctr"/>
+          <a:lstStyle/>
+          <a:p>
+            <a:pPr algn="ctr"/>
+          </a:p>
+        </p:txBody>
+      </p:sp>
+      <p:sp>
+        <p:nvSpPr>
+          <p:cNvPr id="34" name="Rectangle 33"/>
           <p:cNvSpPr/>
           <p:nvPr/>
         </p:nvSpPr>
@@ -7278,7 +7450,7 @@
       </p:sp>
       <p:sp>
         <p:nvSpPr>
-          <p:cNvPr id="31" name="Rectangle 30"/>
+          <p:cNvPr id="35" name="Rectangle 34"/>
           <p:cNvSpPr/>
           <p:nvPr/>
         </p:nvSpPr>
@@ -7321,49 +7493,7 @@
       </p:sp>
       <p:sp>
         <p:nvSpPr>
-          <p:cNvPr id="32" name="TextBox 31"/>
-          <p:cNvSpPr txBox="1"/>
-          <p:nvPr/>
-        </p:nvSpPr>
-        <p:spPr>
-          <a:xfrm>
-            <a:off x="2743200" y="2505456"/>
-            <a:ext cx="7022592" cy="274320"/>
-          </a:xfrm>
-          <a:prstGeom prst="rect">
-            <a:avLst/>
-          </a:prstGeom>
-          <a:noFill/>
-        </p:spPr>
-        <p:txBody>
-          <a:bodyPr wrap="square" lIns="0" rIns="0" tIns="0" bIns="0" anchor="ctr"/>
-          <a:lstStyle/>
-          <a:p>
-            <a:pPr algn="ctr">
-              <a:spcBef>
-                <a:spcPts val="0"/>
-              </a:spcBef>
-              <a:spcAft>
-                <a:spcPts val="0"/>
-              </a:spcAft>
-            </a:pPr>
-            <a:r>
-              <a:rPr sz="1200" b="1">
-                <a:solidFill>
-                  <a:srgbClr val="145A96"/>
-                </a:solidFill>
-                <a:latin typeface="Microsoft YaHei"/>
-                <a:ea typeface="Microsoft YaHei"/>
-                <a:cs typeface="Microsoft YaHei"/>
-              </a:rPr>
-              <a:t>依赖：该层历史 KV 到位，本地才能算这一层</a:t>
-            </a:r>
-          </a:p>
-        </p:txBody>
-      </p:sp>
-      <p:sp>
-        <p:nvSpPr>
-          <p:cNvPr id="33" name="Rectangle 32"/>
+          <p:cNvPr id="36" name="Rectangle 35"/>
           <p:cNvSpPr/>
           <p:nvPr/>
         </p:nvSpPr>
@@ -7408,7 +7538,7 @@
       </p:sp>
       <p:sp>
         <p:nvSpPr>
-          <p:cNvPr id="34" name="Rectangle 33"/>
+          <p:cNvPr id="37" name="Rectangle 36"/>
           <p:cNvSpPr/>
           <p:nvPr/>
         </p:nvSpPr>
@@ -7451,7 +7581,7 @@
       </p:sp>
       <p:sp>
         <p:nvSpPr>
-          <p:cNvPr id="35" name="TextBox 34"/>
+          <p:cNvPr id="38" name="TextBox 37"/>
           <p:cNvSpPr txBox="1"/>
           <p:nvPr/>
         </p:nvSpPr>
@@ -7493,7 +7623,7 @@
       </p:sp>
       <p:sp>
         <p:nvSpPr>
-          <p:cNvPr id="36" name="TextBox 35"/>
+          <p:cNvPr id="39" name="TextBox 38"/>
           <p:cNvSpPr txBox="1"/>
           <p:nvPr/>
         </p:nvSpPr>
@@ -7528,14 +7658,14 @@
                 <a:ea typeface="Microsoft YaHei"/>
                 <a:cs typeface="Microsoft YaHei"/>
               </a:rPr>
-              <a:t>历史 2 到历史 4 的读取，落在上一层本地重计算的时间里。重算 1 与历史 2 同时进行，重算 2 与历史 3 同时进行。</a:t>
-            </a:r>
-          </a:p>
-        </p:txBody>
-      </p:sp>
-      <p:sp>
-        <p:nvSpPr>
-          <p:cNvPr id="37" name="Rectangle 36"/>
+              <a:t>上下对齐的是同一时刻，不是同一层。层2 KV 在算层1 的时间里读，层3 KV 在算层2 的时间里读，层4 KV 在算层3 的时间里读。</a:t>
+            </a:r>
+          </a:p>
+        </p:txBody>
+      </p:sp>
+      <p:sp>
+        <p:nvSpPr>
+          <p:cNvPr id="40" name="Rectangle 39"/>
           <p:cNvSpPr/>
           <p:nvPr/>
         </p:nvSpPr>
@@ -7580,7 +7710,7 @@
       </p:sp>
       <p:sp>
         <p:nvSpPr>
-          <p:cNvPr id="38" name="Rectangle 37"/>
+          <p:cNvPr id="41" name="Rectangle 40"/>
           <p:cNvSpPr/>
           <p:nvPr/>
         </p:nvSpPr>
@@ -7623,7 +7753,7 @@
       </p:sp>
       <p:sp>
         <p:nvSpPr>
-          <p:cNvPr id="39" name="TextBox 38"/>
+          <p:cNvPr id="42" name="TextBox 41"/>
           <p:cNvSpPr txBox="1"/>
           <p:nvPr/>
         </p:nvSpPr>
@@ -7665,7 +7795,7 @@
       </p:sp>
       <p:sp>
         <p:nvSpPr>
-          <p:cNvPr id="40" name="TextBox 39"/>
+          <p:cNvPr id="43" name="TextBox 42"/>
           <p:cNvSpPr txBox="1"/>
           <p:nvPr/>
         </p:nvSpPr>
@@ -7700,14 +7830,14 @@
                 <a:ea typeface="Microsoft YaHei"/>
                 <a:cs typeface="Microsoft YaHei"/>
               </a:rPr>
-              <a:t>本地一层已经算完，下一层历史 KV 还没到，中间就是等待。池带宽变低、历史段变长，等待变长。更便宜的一小段改在本地重算，可以把等待拿掉。</a:t>
-            </a:r>
-          </a:p>
-        </p:txBody>
-      </p:sp>
-      <p:sp>
-        <p:nvSpPr>
-          <p:cNvPr id="41" name="Rectangle 40"/>
+              <a:t>算层 i 已经结束，层 i+1 的 KV 还没读完。珊瑚色的「等层 i+1」就是露出。池带宽变低或历史段变长，这段变长。</a:t>
+            </a:r>
+          </a:p>
+        </p:txBody>
+      </p:sp>
+      <p:sp>
+        <p:nvSpPr>
+          <p:cNvPr id="44" name="Rectangle 43"/>
           <p:cNvSpPr/>
           <p:nvPr/>
         </p:nvSpPr>
@@ -7752,7 +7882,7 @@
       </p:sp>
       <p:sp>
         <p:nvSpPr>
-          <p:cNvPr id="42" name="Rectangle 41"/>
+          <p:cNvPr id="45" name="Rectangle 44"/>
           <p:cNvSpPr/>
           <p:nvPr/>
         </p:nvSpPr>
@@ -7795,7 +7925,7 @@
       </p:sp>
       <p:sp>
         <p:nvSpPr>
-          <p:cNvPr id="43" name="TextBox 42"/>
+          <p:cNvPr id="46" name="TextBox 45"/>
           <p:cNvSpPr txBox="1"/>
           <p:nvPr/>
         </p:nvSpPr>
@@ -7837,7 +7967,7 @@
       </p:sp>
       <p:sp>
         <p:nvSpPr>
-          <p:cNvPr id="44" name="TextBox 43"/>
+          <p:cNvPr id="47" name="TextBox 46"/>
           <p:cNvSpPr txBox="1"/>
           <p:nvPr/>
         </p:nvSpPr>
@@ -7872,14 +8002,14 @@
                 <a:ea typeface="Microsoft YaHei"/>
                 <a:cs typeface="Microsoft YaHei"/>
               </a:rPr>
-              <a:t>汇合在首 token 之前，等待直接进入 TTFT。上一页的露出在首 token 和第 2 token 之间，这一页的露出在首 token 之前。</a:t>
-            </a:r>
-          </a:p>
-        </p:txBody>
-      </p:sp>
-      <p:sp>
-        <p:nvSpPr>
-          <p:cNvPr id="45" name="TextBox 44"/>
+              <a:t>层4 KV 读完才能算层4，算完才出首 token。等待在首 token 之前，直接进入 TTFT。</a:t>
+            </a:r>
+          </a:p>
+        </p:txBody>
+      </p:sp>
+      <p:sp>
+        <p:nvSpPr>
+          <p:cNvPr id="48" name="TextBox 47"/>
           <p:cNvSpPr txBox="1"/>
           <p:nvPr/>
         </p:nvSpPr>

</xml_diff>